<commit_message>
Align resource site with presentation title and deck
</commit_message>
<xml_diff>
--- a/resources/presentation/build-interactive-and-visual-media-with-ai-v3.pptx
+++ b/resources/presentation/build-interactive-and-visual-media-with-ai-v3.pptx
@@ -3379,7 +3379,7 @@
         <p:spPr>
           <a:xfrm>
             <a:off x="731520" y="1298448"/>
-            <a:ext cx="7452360" cy="914400"/>
+            <a:ext cx="7982174" cy="914400"/>
           </a:xfrm>
           <a:prstGeom prst="rect">
             <a:avLst/>
@@ -3400,41 +3400,24 @@
           </a:bodyPr>
           <a:lstStyle/>
           <a:p>
-            <a:pPr marL="0" marR="0" lvl="0" indent="0" algn="l" defTabSz="914400" rtl="0" eaLnBrk="1" fontAlgn="auto" latinLnBrk="0" hangingPunct="1">
-              <a:lnSpc>
-                <a:spcPct val="100000"/>
-              </a:lnSpc>
+            <a:pPr lvl="0" algn="l">
               <a:spcBef>
                 <a:spcPts val="0"/>
               </a:spcBef>
-              <a:spcAft>
-                <a:spcPts val="0"/>
-              </a:spcAft>
-              <a:buClrTx/>
-              <a:buSzTx/>
-              <a:buFontTx/>
-              <a:buNone/>
-              <a:tabLst/>
               <a:defRPr/>
             </a:pPr>
             <a:r>
-              <a:rPr kumimoji="0" lang="en-US" sz="3200" b="1" i="0" u="none" strike="noStrike" kern="1200" cap="none" spc="0" normalizeH="0" baseline="0" noProof="0" dirty="0">
-                <a:ln>
-                  <a:noFill/>
-                </a:ln>
-                <a:solidFill>
-                  <a:srgbClr val="FFFFFF"/>
-                </a:solidFill>
-                <a:effectLst/>
-                <a:uLnTx/>
-                <a:uFillTx/>
-                <a:latin typeface="Georgia" pitchFamily="34" charset="0"/>
-                <a:ea typeface="Georgia" pitchFamily="34" charset="-122"/>
-                <a:cs typeface="Georgia" pitchFamily="34" charset="-120"/>
-              </a:rPr>
-              <a:t>Ideate. Iterate. Implement.</a:t>
-            </a:r>
-            <a:endParaRPr kumimoji="0" lang="en-US" sz="3200" b="0" i="0" u="none" strike="noStrike" kern="1200" cap="none" spc="0" normalizeH="0" baseline="0" noProof="0" dirty="0">
+              <a:rPr lang="en-US" sz="3200" b="1" dirty="0">
+                <a:solidFill>
+                  <a:srgbClr val="DCE4F2"/>
+                </a:solidFill>
+                <a:latin typeface="Aptos" pitchFamily="34" charset="0"/>
+                <a:ea typeface="Aptos" pitchFamily="34" charset="-122"/>
+                <a:cs typeface="Aptos" pitchFamily="34" charset="-120"/>
+              </a:rPr>
+              <a:t>Build Interactive and Visual Media with AI </a:t>
+            </a:r>
+            <a:endParaRPr kumimoji="0" lang="en-US" sz="3200" b="1" i="0" u="none" strike="noStrike" kern="1200" cap="none" spc="0" normalizeH="0" baseline="0" noProof="0" dirty="0">
               <a:ln>
                 <a:noFill/>
               </a:ln>
@@ -3494,47 +3477,6 @@
       </p:sp>
       <p:sp>
         <p:nvSpPr>
-          <p:cNvPr id="7" name="Text 5"/>
-          <p:cNvSpPr/>
-          <p:nvPr/>
-        </p:nvSpPr>
-        <p:spPr>
-          <a:xfrm>
-            <a:off x="731520" y="1755648"/>
-            <a:ext cx="7315200" cy="594360"/>
-          </a:xfrm>
-          <a:prstGeom prst="rect">
-            <a:avLst/>
-          </a:prstGeom>
-          <a:noFill/>
-          <a:ln/>
-        </p:spPr>
-        <p:txBody>
-          <a:bodyPr wrap="square" lIns="0" tIns="0" rIns="0" bIns="0" rtlCol="0" anchor="ctr">
-            <a:normAutofit/>
-          </a:bodyPr>
-          <a:lstStyle/>
-          <a:p>
-            <a:pPr marL="0" indent="0">
-              <a:buNone/>
-            </a:pPr>
-            <a:r>
-              <a:rPr lang="en-US" sz="2100" dirty="0">
-                <a:solidFill>
-                  <a:srgbClr val="DCE4F2"/>
-                </a:solidFill>
-                <a:latin typeface="Aptos" pitchFamily="34" charset="0"/>
-                <a:ea typeface="Aptos" pitchFamily="34" charset="-122"/>
-                <a:cs typeface="Aptos" pitchFamily="34" charset="-120"/>
-              </a:rPr>
-              <a:t>AI-Assisted Interactive Learning Design</a:t>
-            </a:r>
-            <a:endParaRPr lang="en-US" sz="2100" dirty="0"/>
-          </a:p>
-        </p:txBody>
-      </p:sp>
-      <p:sp>
-        <p:nvSpPr>
           <p:cNvPr id="4" name="Shape 2">
             <a:extLst>
               <a:ext uri="{C183D7F6-B498-43B3-948B-1728B52AA6E4}">
@@ -3629,8 +3571,8 @@
         </p:nvSpPr>
         <p:spPr>
           <a:xfrm>
-            <a:off x="634701" y="2931191"/>
-            <a:ext cx="10922598" cy="2844861"/>
+            <a:off x="731519" y="2931191"/>
+            <a:ext cx="10825779" cy="2844861"/>
           </a:xfrm>
           <a:prstGeom prst="roundRect">
             <a:avLst>
@@ -3682,7 +3624,7 @@
         </p:nvSpPr>
         <p:spPr>
           <a:xfrm>
-            <a:off x="1473796" y="3011021"/>
+            <a:off x="1545512" y="3011021"/>
             <a:ext cx="9252470" cy="594360"/>
           </a:xfrm>
           <a:prstGeom prst="rect">
@@ -3726,7 +3668,7 @@
         </p:nvSpPr>
         <p:spPr>
           <a:xfrm>
-            <a:off x="879435" y="3086845"/>
+            <a:off x="951151" y="3086845"/>
             <a:ext cx="7834259" cy="2998154"/>
           </a:xfrm>
           <a:prstGeom prst="rect">
@@ -3833,7 +3775,7 @@
         </p:blipFill>
         <p:spPr>
           <a:xfrm>
-            <a:off x="879435" y="2990984"/>
+            <a:off x="951151" y="2990984"/>
             <a:ext cx="594361" cy="594361"/>
           </a:xfrm>
           <a:prstGeom prst="rect">
@@ -3841,6 +3783,276 @@
           </a:prstGeom>
         </p:spPr>
       </p:pic>
+      <p:sp>
+        <p:nvSpPr>
+          <p:cNvPr id="3" name="Shape 10">
+            <a:extLst>
+              <a:ext uri="{FF2B5EF4-FFF2-40B4-BE49-F238E27FC236}">
+                <a16:creationId xmlns:a16="http://schemas.microsoft.com/office/drawing/2014/main" id="{E7D25929-7ECF-DEE9-E14D-508D34AEC449}"/>
+              </a:ext>
+              <a:ext uri="{C183D7F6-B498-43B3-948B-1728B52AA6E4}">
+                <adec:decorative xmlns:adec="http://schemas.microsoft.com/office/drawing/2017/decorative" val="1"/>
+              </a:ext>
+            </a:extLst>
+          </p:cNvPr>
+          <p:cNvSpPr/>
+          <p:nvPr/>
+        </p:nvSpPr>
+        <p:spPr>
+          <a:xfrm>
+            <a:off x="731520" y="1904624"/>
+            <a:ext cx="1234440" cy="384048"/>
+          </a:xfrm>
+          <a:prstGeom prst="roundRect">
+            <a:avLst>
+              <a:gd name="adj" fmla="val 28571"/>
+            </a:avLst>
+          </a:prstGeom>
+          <a:solidFill>
+            <a:srgbClr val="4F6FAE"/>
+          </a:solidFill>
+          <a:ln w="12700">
+            <a:solidFill>
+              <a:srgbClr val="4F6FAE"/>
+            </a:solidFill>
+            <a:prstDash val="solid"/>
+          </a:ln>
+        </p:spPr>
+        <p:txBody>
+          <a:bodyPr/>
+          <a:lstStyle/>
+          <a:p>
+            <a:endParaRPr lang="en-US"/>
+          </a:p>
+        </p:txBody>
+      </p:sp>
+      <p:sp>
+        <p:nvSpPr>
+          <p:cNvPr id="9" name="Text 11">
+            <a:extLst>
+              <a:ext uri="{FF2B5EF4-FFF2-40B4-BE49-F238E27FC236}">
+                <a16:creationId xmlns:a16="http://schemas.microsoft.com/office/drawing/2014/main" id="{522792EA-3292-3419-32D2-79168D192A64}"/>
+              </a:ext>
+            </a:extLst>
+          </p:cNvPr>
+          <p:cNvSpPr/>
+          <p:nvPr/>
+        </p:nvSpPr>
+        <p:spPr>
+          <a:xfrm>
+            <a:off x="841248" y="1904624"/>
+            <a:ext cx="1014984" cy="384048"/>
+          </a:xfrm>
+          <a:prstGeom prst="rect">
+            <a:avLst/>
+          </a:prstGeom>
+          <a:noFill/>
+          <a:ln/>
+        </p:spPr>
+        <p:txBody>
+          <a:bodyPr wrap="square" lIns="0" tIns="0" rIns="0" bIns="0" rtlCol="0" anchor="ctr">
+            <a:normAutofit/>
+          </a:bodyPr>
+          <a:lstStyle/>
+          <a:p>
+            <a:pPr marL="0" indent="0" algn="ctr">
+              <a:buNone/>
+            </a:pPr>
+            <a:r>
+              <a:rPr lang="en-US" sz="1100" b="1" dirty="0">
+                <a:solidFill>
+                  <a:srgbClr val="FFFFFF"/>
+                </a:solidFill>
+                <a:latin typeface="Aptos" pitchFamily="34" charset="0"/>
+                <a:ea typeface="Aptos" pitchFamily="34" charset="-122"/>
+                <a:cs typeface="Aptos" pitchFamily="34" charset="-120"/>
+              </a:rPr>
+              <a:t>IDEATE</a:t>
+            </a:r>
+            <a:endParaRPr lang="en-US" sz="1100" dirty="0"/>
+          </a:p>
+        </p:txBody>
+      </p:sp>
+      <p:sp>
+        <p:nvSpPr>
+          <p:cNvPr id="10" name="Shape 12">
+            <a:extLst>
+              <a:ext uri="{FF2B5EF4-FFF2-40B4-BE49-F238E27FC236}">
+                <a16:creationId xmlns:a16="http://schemas.microsoft.com/office/drawing/2014/main" id="{271346A4-2949-C930-A6C4-2F8569B980A2}"/>
+              </a:ext>
+              <a:ext uri="{C183D7F6-B498-43B3-948B-1728B52AA6E4}">
+                <adec:decorative xmlns:adec="http://schemas.microsoft.com/office/drawing/2017/decorative" val="1"/>
+              </a:ext>
+            </a:extLst>
+          </p:cNvPr>
+          <p:cNvSpPr/>
+          <p:nvPr/>
+        </p:nvSpPr>
+        <p:spPr>
+          <a:xfrm>
+            <a:off x="2139696" y="1904624"/>
+            <a:ext cx="1325880" cy="384048"/>
+          </a:xfrm>
+          <a:prstGeom prst="roundRect">
+            <a:avLst>
+              <a:gd name="adj" fmla="val 28571"/>
+            </a:avLst>
+          </a:prstGeom>
+          <a:solidFill>
+            <a:srgbClr val="D5B979"/>
+          </a:solidFill>
+          <a:ln w="12700">
+            <a:solidFill>
+              <a:srgbClr val="D5B979"/>
+            </a:solidFill>
+            <a:prstDash val="solid"/>
+          </a:ln>
+        </p:spPr>
+        <p:txBody>
+          <a:bodyPr/>
+          <a:lstStyle/>
+          <a:p>
+            <a:endParaRPr lang="en-US"/>
+          </a:p>
+        </p:txBody>
+      </p:sp>
+      <p:sp>
+        <p:nvSpPr>
+          <p:cNvPr id="11" name="Text 13">
+            <a:extLst>
+              <a:ext uri="{FF2B5EF4-FFF2-40B4-BE49-F238E27FC236}">
+                <a16:creationId xmlns:a16="http://schemas.microsoft.com/office/drawing/2014/main" id="{52714165-1E13-B1C4-1DA8-8B23DE1EC6D9}"/>
+              </a:ext>
+            </a:extLst>
+          </p:cNvPr>
+          <p:cNvSpPr/>
+          <p:nvPr/>
+        </p:nvSpPr>
+        <p:spPr>
+          <a:xfrm>
+            <a:off x="2249424" y="1904624"/>
+            <a:ext cx="1106424" cy="384048"/>
+          </a:xfrm>
+          <a:prstGeom prst="rect">
+            <a:avLst/>
+          </a:prstGeom>
+          <a:noFill/>
+          <a:ln/>
+        </p:spPr>
+        <p:txBody>
+          <a:bodyPr wrap="square" lIns="0" tIns="0" rIns="0" bIns="0" rtlCol="0" anchor="ctr">
+            <a:normAutofit/>
+          </a:bodyPr>
+          <a:lstStyle/>
+          <a:p>
+            <a:pPr marL="0" indent="0" algn="ctr">
+              <a:buNone/>
+            </a:pPr>
+            <a:r>
+              <a:rPr lang="en-US" sz="1100" b="1" dirty="0">
+                <a:solidFill>
+                  <a:srgbClr val="17254E"/>
+                </a:solidFill>
+                <a:latin typeface="Aptos" pitchFamily="34" charset="0"/>
+                <a:ea typeface="Aptos" pitchFamily="34" charset="-122"/>
+                <a:cs typeface="Aptos" pitchFamily="34" charset="-120"/>
+              </a:rPr>
+              <a:t>ITERATE</a:t>
+            </a:r>
+            <a:endParaRPr lang="en-US" sz="1100" dirty="0"/>
+          </a:p>
+        </p:txBody>
+      </p:sp>
+      <p:sp>
+        <p:nvSpPr>
+          <p:cNvPr id="12" name="Shape 14">
+            <a:extLst>
+              <a:ext uri="{FF2B5EF4-FFF2-40B4-BE49-F238E27FC236}">
+                <a16:creationId xmlns:a16="http://schemas.microsoft.com/office/drawing/2014/main" id="{5108D90A-8E74-1183-C533-DEAB954B34EE}"/>
+              </a:ext>
+              <a:ext uri="{C183D7F6-B498-43B3-948B-1728B52AA6E4}">
+                <adec:decorative xmlns:adec="http://schemas.microsoft.com/office/drawing/2017/decorative" val="1"/>
+              </a:ext>
+            </a:extLst>
+          </p:cNvPr>
+          <p:cNvSpPr/>
+          <p:nvPr/>
+        </p:nvSpPr>
+        <p:spPr>
+          <a:xfrm>
+            <a:off x="3639312" y="1904624"/>
+            <a:ext cx="1508760" cy="384048"/>
+          </a:xfrm>
+          <a:prstGeom prst="roundRect">
+            <a:avLst>
+              <a:gd name="adj" fmla="val 28571"/>
+            </a:avLst>
+          </a:prstGeom>
+          <a:solidFill>
+            <a:srgbClr val="149966"/>
+          </a:solidFill>
+          <a:ln w="12700">
+            <a:solidFill>
+              <a:srgbClr val="149966"/>
+            </a:solidFill>
+            <a:prstDash val="solid"/>
+          </a:ln>
+        </p:spPr>
+        <p:txBody>
+          <a:bodyPr/>
+          <a:lstStyle/>
+          <a:p>
+            <a:endParaRPr lang="en-US"/>
+          </a:p>
+        </p:txBody>
+      </p:sp>
+      <p:sp>
+        <p:nvSpPr>
+          <p:cNvPr id="13" name="Text 15">
+            <a:extLst>
+              <a:ext uri="{FF2B5EF4-FFF2-40B4-BE49-F238E27FC236}">
+                <a16:creationId xmlns:a16="http://schemas.microsoft.com/office/drawing/2014/main" id="{61F9D9A0-59D4-0556-716E-8E0CB2A8D327}"/>
+              </a:ext>
+            </a:extLst>
+          </p:cNvPr>
+          <p:cNvSpPr/>
+          <p:nvPr/>
+        </p:nvSpPr>
+        <p:spPr>
+          <a:xfrm>
+            <a:off x="3749040" y="1904624"/>
+            <a:ext cx="1289304" cy="384048"/>
+          </a:xfrm>
+          <a:prstGeom prst="rect">
+            <a:avLst/>
+          </a:prstGeom>
+          <a:noFill/>
+          <a:ln/>
+        </p:spPr>
+        <p:txBody>
+          <a:bodyPr wrap="square" lIns="0" tIns="0" rIns="0" bIns="0" rtlCol="0" anchor="ctr">
+            <a:normAutofit/>
+          </a:bodyPr>
+          <a:lstStyle/>
+          <a:p>
+            <a:pPr marL="0" indent="0" algn="ctr">
+              <a:buNone/>
+            </a:pPr>
+            <a:r>
+              <a:rPr lang="en-US" sz="1100" b="1" dirty="0">
+                <a:solidFill>
+                  <a:srgbClr val="FFFFFF"/>
+                </a:solidFill>
+                <a:latin typeface="Aptos" pitchFamily="34" charset="0"/>
+                <a:ea typeface="Aptos" pitchFamily="34" charset="-122"/>
+                <a:cs typeface="Aptos" pitchFamily="34" charset="-120"/>
+              </a:rPr>
+              <a:t>IMPLEMENT</a:t>
+            </a:r>
+            <a:endParaRPr lang="en-US" sz="1100" dirty="0"/>
+          </a:p>
+        </p:txBody>
+      </p:sp>
     </p:spTree>
   </p:cSld>
   <p:clrMapOvr>

</xml_diff>

<commit_message>
Update presentation and participant package
</commit_message>
<xml_diff>
--- a/resources/presentation/build-interactive-and-visual-media-with-ai-v3.pptx
+++ b/resources/presentation/build-interactive-and-visual-media-with-ai-v3.pptx
@@ -142,6 +142,106 @@
     </p:ext>
   </p:extLst>
 </p:presentation>
+</file>
+
+<file path=ppt/revisionInfo.xml><?xml version="1.0" encoding="utf-8"?>
+<p1510:revInfo xmlns:a="http://schemas.openxmlformats.org/drawingml/2006/main" xmlns:r="http://schemas.openxmlformats.org/officeDocument/2006/relationships" xmlns:p1510="http://schemas.microsoft.com/office/powerpoint/2015/10/main">
+  <p1510:revLst>
+    <p1510:client id="{1BDFA1FC-C496-EC41-8EEA-76EB65C64ADF}" v="2" dt="2026-07-17T14:07:29.279"/>
+  </p1510:revLst>
+</p1510:revInfo>
+</file>
+
+<file path=ppt/changesInfos/changesInfo1.xml><?xml version="1.0" encoding="utf-8"?>
+<pc:chgInfo xmlns:a="http://schemas.openxmlformats.org/drawingml/2006/main" xmlns:r="http://schemas.openxmlformats.org/officeDocument/2006/relationships" xmlns:ac="http://schemas.microsoft.com/office/drawing/2013/main/command" xmlns:pc="http://schemas.microsoft.com/office/powerpoint/2013/main/command">
+  <pc:docChgLst>
+    <pc:chgData name="Allan, John" userId="e8ef1c47-ed91-448d-adaf-3df63196cc6d" providerId="ADAL" clId="{954915EC-4E4C-5938-BB5E-75752EC955AC}"/>
+    <pc:docChg chg="undo custSel modSld">
+      <pc:chgData name="Allan, John" userId="e8ef1c47-ed91-448d-adaf-3df63196cc6d" providerId="ADAL" clId="{954915EC-4E4C-5938-BB5E-75752EC955AC}" dt="2026-07-17T14:08:25.844" v="9" actId="13244"/>
+      <pc:docMkLst>
+        <pc:docMk/>
+      </pc:docMkLst>
+      <pc:sldChg chg="addSp delSp modSp mod">
+        <pc:chgData name="Allan, John" userId="e8ef1c47-ed91-448d-adaf-3df63196cc6d" providerId="ADAL" clId="{954915EC-4E4C-5938-BB5E-75752EC955AC}" dt="2026-07-17T14:08:06.273" v="7" actId="962"/>
+        <pc:sldMkLst>
+          <pc:docMk/>
+          <pc:sldMk cId="0" sldId="256"/>
+        </pc:sldMkLst>
+        <pc:spChg chg="ord">
+          <ac:chgData name="Allan, John" userId="e8ef1c47-ed91-448d-adaf-3df63196cc6d" providerId="ADAL" clId="{954915EC-4E4C-5938-BB5E-75752EC955AC}" dt="2026-07-17T14:07:44.587" v="4" actId="13244"/>
+          <ac:spMkLst>
+            <pc:docMk/>
+            <pc:sldMk cId="0" sldId="256"/>
+            <ac:spMk id="2" creationId="{00000000-0000-0000-0000-000000000000}"/>
+          </ac:spMkLst>
+        </pc:spChg>
+        <pc:spChg chg="add del mod">
+          <ac:chgData name="Allan, John" userId="e8ef1c47-ed91-448d-adaf-3df63196cc6d" providerId="ADAL" clId="{954915EC-4E4C-5938-BB5E-75752EC955AC}" dt="2026-07-17T14:07:31.466" v="3" actId="21"/>
+          <ac:spMkLst>
+            <pc:docMk/>
+            <pc:sldMk cId="0" sldId="256"/>
+            <ac:spMk id="7" creationId="{B03AD48F-8DD0-D9F9-17DF-C57C90D09C57}"/>
+          </ac:spMkLst>
+        </pc:spChg>
+        <pc:spChg chg="ord">
+          <ac:chgData name="Allan, John" userId="e8ef1c47-ed91-448d-adaf-3df63196cc6d" providerId="ADAL" clId="{954915EC-4E4C-5938-BB5E-75752EC955AC}" dt="2026-07-17T14:07:56.665" v="5" actId="13244"/>
+          <ac:spMkLst>
+            <pc:docMk/>
+            <pc:sldMk cId="0" sldId="256"/>
+            <ac:spMk id="26" creationId="{08510B24-1BFD-9367-3F17-0381849B1AB1}"/>
+          </ac:spMkLst>
+        </pc:spChg>
+        <pc:spChg chg="mod ord">
+          <ac:chgData name="Allan, John" userId="e8ef1c47-ed91-448d-adaf-3df63196cc6d" providerId="ADAL" clId="{954915EC-4E4C-5938-BB5E-75752EC955AC}" dt="2026-07-17T14:07:59.358" v="6" actId="13244"/>
+          <ac:spMkLst>
+            <pc:docMk/>
+            <pc:sldMk cId="0" sldId="256"/>
+            <ac:spMk id="28" creationId="{7B7FCFC5-57E4-BCF0-1B3C-BBD235D71835}"/>
+          </ac:spMkLst>
+        </pc:spChg>
+        <pc:picChg chg="mod">
+          <ac:chgData name="Allan, John" userId="e8ef1c47-ed91-448d-adaf-3df63196cc6d" providerId="ADAL" clId="{954915EC-4E4C-5938-BB5E-75752EC955AC}" dt="2026-07-17T14:08:06.273" v="7" actId="962"/>
+          <ac:picMkLst>
+            <pc:docMk/>
+            <pc:sldMk cId="0" sldId="256"/>
+            <ac:picMk id="8" creationId="{CDBBAA35-14EA-B484-78BD-EC378F88B02A}"/>
+          </ac:picMkLst>
+        </pc:picChg>
+      </pc:sldChg>
+      <pc:sldChg chg="modSp mod">
+        <pc:chgData name="Allan, John" userId="e8ef1c47-ed91-448d-adaf-3df63196cc6d" providerId="ADAL" clId="{954915EC-4E4C-5938-BB5E-75752EC955AC}" dt="2026-07-17T14:08:25.844" v="9" actId="13244"/>
+        <pc:sldMkLst>
+          <pc:docMk/>
+          <pc:sldMk cId="0" sldId="283"/>
+        </pc:sldMkLst>
+        <pc:spChg chg="ord">
+          <ac:chgData name="Allan, John" userId="e8ef1c47-ed91-448d-adaf-3df63196cc6d" providerId="ADAL" clId="{954915EC-4E4C-5938-BB5E-75752EC955AC}" dt="2026-07-17T14:08:22.157" v="8" actId="13244"/>
+          <ac:spMkLst>
+            <pc:docMk/>
+            <pc:sldMk cId="0" sldId="283"/>
+            <ac:spMk id="7" creationId="{00000000-0000-0000-0000-000000000000}"/>
+          </ac:spMkLst>
+        </pc:spChg>
+        <pc:spChg chg="ord">
+          <ac:chgData name="Allan, John" userId="e8ef1c47-ed91-448d-adaf-3df63196cc6d" providerId="ADAL" clId="{954915EC-4E4C-5938-BB5E-75752EC955AC}" dt="2026-07-17T14:08:25.844" v="9" actId="13244"/>
+          <ac:spMkLst>
+            <pc:docMk/>
+            <pc:sldMk cId="0" sldId="283"/>
+            <ac:spMk id="12" creationId="{B3A9AF9A-061B-5BBD-969B-6F3256982E65}"/>
+          </ac:spMkLst>
+        </pc:spChg>
+        <pc:spChg chg="ord">
+          <ac:chgData name="Allan, John" userId="e8ef1c47-ed91-448d-adaf-3df63196cc6d" providerId="ADAL" clId="{954915EC-4E4C-5938-BB5E-75752EC955AC}" dt="2026-07-17T14:08:25.844" v="9" actId="13244"/>
+          <ac:spMkLst>
+            <pc:docMk/>
+            <pc:sldMk cId="0" sldId="283"/>
+            <ac:spMk id="28" creationId="{451DB6DC-4810-2B8C-34FA-0A12EC8C80F7}"/>
+          </ac:spMkLst>
+        </pc:spChg>
+      </pc:sldChg>
+    </pc:docChg>
+  </pc:docChgLst>
+</pc:chgInfo>
 </file>
 
 <file path=ppt/notesMasters/notesMaster1.xml><?xml version="1.0" encoding="utf-8"?>
@@ -3515,47 +3615,6 @@
       </p:sp>
       <p:sp>
         <p:nvSpPr>
-          <p:cNvPr id="2" name="Text 0"/>
-          <p:cNvSpPr/>
-          <p:nvPr/>
-        </p:nvSpPr>
-        <p:spPr>
-          <a:xfrm>
-            <a:off x="594360" y="6510528"/>
-            <a:ext cx="5943600" cy="164592"/>
-          </a:xfrm>
-          <a:prstGeom prst="rect">
-            <a:avLst/>
-          </a:prstGeom>
-          <a:noFill/>
-          <a:ln/>
-        </p:spPr>
-        <p:txBody>
-          <a:bodyPr wrap="square" lIns="0" tIns="0" rIns="0" bIns="0" rtlCol="0" anchor="ctr">
-            <a:normAutofit/>
-          </a:bodyPr>
-          <a:lstStyle/>
-          <a:p>
-            <a:pPr marL="0" indent="0">
-              <a:buNone/>
-            </a:pPr>
-            <a:r>
-              <a:rPr lang="en-US" sz="800" dirty="0">
-                <a:solidFill>
-                  <a:srgbClr val="BFC9DB"/>
-                </a:solidFill>
-                <a:latin typeface="Aptos" pitchFamily="34" charset="0"/>
-                <a:ea typeface="Aptos" pitchFamily="34" charset="-122"/>
-                <a:cs typeface="Aptos" pitchFamily="34" charset="-120"/>
-              </a:rPr>
-              <a:t>Hillsborough College  |  Summer Institute 2026</a:t>
-            </a:r>
-            <a:endParaRPr lang="en-US" sz="800" dirty="0"/>
-          </a:p>
-        </p:txBody>
-      </p:sp>
-      <p:sp>
-        <p:nvSpPr>
           <p:cNvPr id="25" name="Rounded Rectangle 24">
             <a:extLst>
               <a:ext uri="{FF2B5EF4-FFF2-40B4-BE49-F238E27FC236}">
@@ -3610,149 +3669,15 @@
           </a:p>
         </p:txBody>
       </p:sp>
-      <p:sp>
-        <p:nvSpPr>
-          <p:cNvPr id="26" name="Text 5">
-            <a:extLst>
-              <a:ext uri="{FF2B5EF4-FFF2-40B4-BE49-F238E27FC236}">
-                <a16:creationId xmlns:a16="http://schemas.microsoft.com/office/drawing/2014/main" id="{08510B24-1BFD-9367-3F17-0381849B1AB1}"/>
-              </a:ext>
-            </a:extLst>
-          </p:cNvPr>
-          <p:cNvSpPr/>
-          <p:nvPr/>
-        </p:nvSpPr>
-        <p:spPr>
-          <a:xfrm>
-            <a:off x="1545512" y="3011021"/>
-            <a:ext cx="9252470" cy="594360"/>
-          </a:xfrm>
-          <a:prstGeom prst="rect">
-            <a:avLst/>
-          </a:prstGeom>
-          <a:noFill/>
-          <a:ln/>
-        </p:spPr>
-        <p:txBody>
-          <a:bodyPr wrap="square" lIns="0" tIns="0" rIns="0" bIns="0" rtlCol="0" anchor="ctr">
-            <a:normAutofit/>
-          </a:bodyPr>
-          <a:lstStyle/>
-          <a:p>
-            <a:pPr marL="0" indent="0">
-              <a:buNone/>
-            </a:pPr>
-            <a:r>
-              <a:rPr lang="en-US" sz="2100" b="1" dirty="0">
-                <a:latin typeface="Aptos" pitchFamily="34" charset="0"/>
-                <a:ea typeface="Aptos" pitchFamily="34" charset="-122"/>
-                <a:cs typeface="Aptos" pitchFamily="34" charset="-120"/>
-              </a:rPr>
-              <a:t>    ACCESS THE PRESENTATION RESOURCE SITE AND PROMPT BUILDER APP</a:t>
-            </a:r>
-            <a:endParaRPr lang="en-US" sz="2100" b="1" dirty="0"/>
-          </a:p>
-        </p:txBody>
-      </p:sp>
-      <p:sp>
-        <p:nvSpPr>
-          <p:cNvPr id="28" name="Text 5">
-            <a:extLst>
-              <a:ext uri="{FF2B5EF4-FFF2-40B4-BE49-F238E27FC236}">
-                <a16:creationId xmlns:a16="http://schemas.microsoft.com/office/drawing/2014/main" id="{7B7FCFC5-57E4-BCF0-1B3C-BBD235D71835}"/>
-              </a:ext>
-            </a:extLst>
-          </p:cNvPr>
-          <p:cNvSpPr/>
-          <p:nvPr/>
-        </p:nvSpPr>
-        <p:spPr>
-          <a:xfrm>
-            <a:off x="951151" y="3086845"/>
-            <a:ext cx="7834259" cy="2998154"/>
-          </a:xfrm>
-          <a:prstGeom prst="rect">
-            <a:avLst/>
-          </a:prstGeom>
-          <a:noFill/>
-          <a:ln/>
-        </p:spPr>
-        <p:txBody>
-          <a:bodyPr wrap="square" lIns="0" tIns="0" rIns="0" bIns="0" rtlCol="0" anchor="ctr">
-            <a:normAutofit/>
-          </a:bodyPr>
-          <a:lstStyle/>
-          <a:p>
-            <a:pPr marL="0" indent="0">
-              <a:buNone/>
-            </a:pPr>
-            <a:r>
-              <a:rPr lang="en-US" sz="2100" dirty="0">
-                <a:latin typeface="Aptos" pitchFamily="34" charset="0"/>
-                <a:ea typeface="Aptos" pitchFamily="34" charset="-122"/>
-                <a:cs typeface="Aptos" pitchFamily="34" charset="-120"/>
-              </a:rPr>
-              <a:t>Visit the </a:t>
-            </a:r>
-            <a:r>
-              <a:rPr lang="en-US" sz="2100" dirty="0">
-                <a:latin typeface="Aptos" pitchFamily="34" charset="0"/>
-                <a:ea typeface="Aptos" pitchFamily="34" charset="-122"/>
-                <a:cs typeface="Aptos" pitchFamily="34" charset="-120"/>
-                <a:hlinkClick r:id="rId3"/>
-              </a:rPr>
-              <a:t>resource site</a:t>
-            </a:r>
-            <a:r>
-              <a:rPr lang="en-US" sz="2100" dirty="0">
-                <a:latin typeface="Aptos" pitchFamily="34" charset="0"/>
-                <a:ea typeface="Aptos" pitchFamily="34" charset="-122"/>
-                <a:cs typeface="Aptos" pitchFamily="34" charset="-120"/>
-              </a:rPr>
-              <a:t> to view and print out the handouts and case studies at your leisure. </a:t>
-            </a:r>
-          </a:p>
-          <a:p>
-            <a:pPr marL="0" indent="0">
-              <a:buNone/>
-            </a:pPr>
-            <a:endParaRPr lang="en-US" sz="2100" dirty="0">
-              <a:latin typeface="Aptos" pitchFamily="34" charset="0"/>
-            </a:endParaRPr>
-          </a:p>
-          <a:p>
-            <a:pPr marL="0" indent="0">
-              <a:buNone/>
-            </a:pPr>
-            <a:r>
-              <a:rPr lang="en-US" sz="2100" dirty="0">
-                <a:latin typeface="Aptos" pitchFamily="34" charset="0"/>
-              </a:rPr>
-              <a:t>Your also welcome to use this </a:t>
-            </a:r>
-            <a:r>
-              <a:rPr lang="en-US" sz="2100" dirty="0">
-                <a:latin typeface="Aptos" pitchFamily="34" charset="0"/>
-                <a:hlinkClick r:id="rId3"/>
-              </a:rPr>
-              <a:t>prompt and context builder app</a:t>
-            </a:r>
-            <a:r>
-              <a:rPr lang="en-US" sz="2100" dirty="0">
-                <a:latin typeface="Aptos" pitchFamily="34" charset="0"/>
-              </a:rPr>
-              <a:t> that’s based on the workflow and model discussed in this same presentation.</a:t>
-            </a:r>
-            <a:endParaRPr lang="en-US" sz="2100" dirty="0"/>
-          </a:p>
-        </p:txBody>
-      </p:sp>
       <p:pic>
         <p:nvPicPr>
-          <p:cNvPr id="8" name="Graphic 7" descr="Internet with solid fill">
+          <p:cNvPr id="8" name="Graphic 7">
             <a:extLst>
               <a:ext uri="{FF2B5EF4-FFF2-40B4-BE49-F238E27FC236}">
                 <a16:creationId xmlns:a16="http://schemas.microsoft.com/office/drawing/2014/main" id="{CDBBAA35-14EA-B484-78BD-EC378F88B02A}"/>
+              </a:ext>
+              <a:ext uri="{C183D7F6-B498-43B3-948B-1728B52AA6E4}">
+                <adec:decorative xmlns:adec="http://schemas.microsoft.com/office/drawing/2017/decorative" val="1"/>
               </a:ext>
             </a:extLst>
           </p:cNvPr>
@@ -3765,7 +3690,7 @@
           <a:blip>
             <a:extLst>
               <a:ext uri="{96DAC541-7B7A-43D3-8B79-37D633B846F1}">
-                <asvg:svgBlip xmlns:asvg="http://schemas.microsoft.com/office/drawing/2016/SVG/main" r:embed="rId4"/>
+                <asvg:svgBlip xmlns:asvg="http://schemas.microsoft.com/office/drawing/2016/SVG/main" r:embed="rId3"/>
               </a:ext>
             </a:extLst>
           </a:blip>
@@ -4050,6 +3975,184 @@
               <a:t>IMPLEMENT</a:t>
             </a:r>
             <a:endParaRPr lang="en-US" sz="1100" dirty="0"/>
+          </a:p>
+        </p:txBody>
+      </p:sp>
+      <p:sp>
+        <p:nvSpPr>
+          <p:cNvPr id="26" name="Text 5">
+            <a:extLst>
+              <a:ext uri="{FF2B5EF4-FFF2-40B4-BE49-F238E27FC236}">
+                <a16:creationId xmlns:a16="http://schemas.microsoft.com/office/drawing/2014/main" id="{08510B24-1BFD-9367-3F17-0381849B1AB1}"/>
+              </a:ext>
+            </a:extLst>
+          </p:cNvPr>
+          <p:cNvSpPr/>
+          <p:nvPr/>
+        </p:nvSpPr>
+        <p:spPr>
+          <a:xfrm>
+            <a:off x="1545512" y="3011021"/>
+            <a:ext cx="9252470" cy="594360"/>
+          </a:xfrm>
+          <a:prstGeom prst="rect">
+            <a:avLst/>
+          </a:prstGeom>
+          <a:noFill/>
+          <a:ln/>
+        </p:spPr>
+        <p:txBody>
+          <a:bodyPr wrap="square" lIns="0" tIns="0" rIns="0" bIns="0" rtlCol="0" anchor="ctr">
+            <a:normAutofit/>
+          </a:bodyPr>
+          <a:lstStyle/>
+          <a:p>
+            <a:pPr marL="0" indent="0">
+              <a:buNone/>
+            </a:pPr>
+            <a:r>
+              <a:rPr lang="en-US" sz="2100" b="1" dirty="0">
+                <a:latin typeface="Aptos" pitchFamily="34" charset="0"/>
+                <a:ea typeface="Aptos" pitchFamily="34" charset="-122"/>
+                <a:cs typeface="Aptos" pitchFamily="34" charset="-120"/>
+              </a:rPr>
+              <a:t>    ACCESS THE PRESENTATION RESOURCE SITE AND PROMPT BUILDER APP</a:t>
+            </a:r>
+            <a:endParaRPr lang="en-US" sz="2100" b="1" dirty="0"/>
+          </a:p>
+        </p:txBody>
+      </p:sp>
+      <p:sp>
+        <p:nvSpPr>
+          <p:cNvPr id="28" name="Text 5">
+            <a:extLst>
+              <a:ext uri="{FF2B5EF4-FFF2-40B4-BE49-F238E27FC236}">
+                <a16:creationId xmlns:a16="http://schemas.microsoft.com/office/drawing/2014/main" id="{7B7FCFC5-57E4-BCF0-1B3C-BBD235D71835}"/>
+              </a:ext>
+            </a:extLst>
+          </p:cNvPr>
+          <p:cNvSpPr/>
+          <p:nvPr/>
+        </p:nvSpPr>
+        <p:spPr>
+          <a:xfrm>
+            <a:off x="951151" y="3086845"/>
+            <a:ext cx="7834259" cy="2998154"/>
+          </a:xfrm>
+          <a:prstGeom prst="rect">
+            <a:avLst/>
+          </a:prstGeom>
+          <a:noFill/>
+          <a:ln/>
+        </p:spPr>
+        <p:txBody>
+          <a:bodyPr wrap="square" lIns="0" tIns="0" rIns="0" bIns="0" rtlCol="0" anchor="ctr">
+            <a:normAutofit/>
+          </a:bodyPr>
+          <a:lstStyle/>
+          <a:p>
+            <a:pPr marL="0" indent="0">
+              <a:buNone/>
+            </a:pPr>
+            <a:r>
+              <a:rPr lang="en-US" sz="2100" dirty="0">
+                <a:latin typeface="Aptos" pitchFamily="34" charset="0"/>
+                <a:ea typeface="Aptos" pitchFamily="34" charset="-122"/>
+                <a:cs typeface="Aptos" pitchFamily="34" charset="-120"/>
+              </a:rPr>
+              <a:t>Visit the </a:t>
+            </a:r>
+            <a:r>
+              <a:rPr lang="en-US" sz="2100" dirty="0">
+                <a:latin typeface="Aptos" pitchFamily="34" charset="0"/>
+                <a:ea typeface="Aptos" pitchFamily="34" charset="-122"/>
+                <a:cs typeface="Aptos" pitchFamily="34" charset="-120"/>
+                <a:hlinkClick r:id="rId4"/>
+              </a:rPr>
+              <a:t>resource site</a:t>
+            </a:r>
+            <a:r>
+              <a:rPr lang="en-US" sz="2100" dirty="0">
+                <a:latin typeface="Aptos" pitchFamily="34" charset="0"/>
+                <a:ea typeface="Aptos" pitchFamily="34" charset="-122"/>
+                <a:cs typeface="Aptos" pitchFamily="34" charset="-120"/>
+              </a:rPr>
+              <a:t> to view and print out the handouts and case studies at your leisure. </a:t>
+            </a:r>
+          </a:p>
+          <a:p>
+            <a:pPr marL="0" indent="0">
+              <a:buNone/>
+            </a:pPr>
+            <a:endParaRPr lang="en-US" sz="2100" dirty="0">
+              <a:latin typeface="Aptos" pitchFamily="34" charset="0"/>
+            </a:endParaRPr>
+          </a:p>
+          <a:p>
+            <a:pPr marL="0" indent="0">
+              <a:buNone/>
+            </a:pPr>
+            <a:r>
+              <a:rPr lang="en-US" sz="2100" dirty="0">
+                <a:latin typeface="Aptos" pitchFamily="34" charset="0"/>
+              </a:rPr>
+              <a:t>Your also welcome to use this </a:t>
+            </a:r>
+            <a:r>
+              <a:rPr lang="en-US" sz="2100" dirty="0">
+                <a:latin typeface="Aptos" pitchFamily="34" charset="0"/>
+                <a:hlinkClick r:id="rId5"/>
+              </a:rPr>
+              <a:t>prompt and context builder app</a:t>
+            </a:r>
+            <a:r>
+              <a:rPr lang="en-US" sz="2100" dirty="0">
+                <a:latin typeface="Aptos" pitchFamily="34" charset="0"/>
+              </a:rPr>
+              <a:t> that’s based on the workflow and model discussed in this same presentation.</a:t>
+            </a:r>
+            <a:endParaRPr lang="en-US" sz="2100" dirty="0"/>
+          </a:p>
+        </p:txBody>
+      </p:sp>
+      <p:sp>
+        <p:nvSpPr>
+          <p:cNvPr id="2" name="Text 0"/>
+          <p:cNvSpPr/>
+          <p:nvPr/>
+        </p:nvSpPr>
+        <p:spPr>
+          <a:xfrm>
+            <a:off x="594360" y="6510528"/>
+            <a:ext cx="5943600" cy="164592"/>
+          </a:xfrm>
+          <a:prstGeom prst="rect">
+            <a:avLst/>
+          </a:prstGeom>
+          <a:noFill/>
+          <a:ln/>
+        </p:spPr>
+        <p:txBody>
+          <a:bodyPr wrap="square" lIns="0" tIns="0" rIns="0" bIns="0" rtlCol="0" anchor="ctr">
+            <a:normAutofit/>
+          </a:bodyPr>
+          <a:lstStyle/>
+          <a:p>
+            <a:pPr marL="0" indent="0">
+              <a:buNone/>
+            </a:pPr>
+            <a:r>
+              <a:rPr lang="en-US" sz="800" dirty="0">
+                <a:solidFill>
+                  <a:srgbClr val="BFC9DB"/>
+                </a:solidFill>
+                <a:latin typeface="Aptos" pitchFamily="34" charset="0"/>
+                <a:ea typeface="Aptos" pitchFamily="34" charset="-122"/>
+                <a:cs typeface="Aptos" pitchFamily="34" charset="-120"/>
+              </a:rPr>
+              <a:t>Hillsborough College  |  Summer Institute 2026</a:t>
+            </a:r>
+            <a:endParaRPr lang="en-US" sz="800" dirty="0"/>
           </a:p>
         </p:txBody>
       </p:sp>
@@ -18566,889 +18669,6 @@
       </p:sp>
       <p:sp>
         <p:nvSpPr>
-          <p:cNvPr id="2" name="Shape 0">
-            <a:extLst>
-              <a:ext uri="{C183D7F6-B498-43B3-948B-1728B52AA6E4}">
-                <adec:decorative xmlns:adec="http://schemas.microsoft.com/office/drawing/2017/decorative" val="1"/>
-              </a:ext>
-            </a:extLst>
-          </p:cNvPr>
-          <p:cNvSpPr/>
-          <p:nvPr/>
-        </p:nvSpPr>
-        <p:spPr>
-          <a:xfrm>
-            <a:off x="0" y="0"/>
-            <a:ext cx="146304" cy="6858000"/>
-          </a:xfrm>
-          <a:prstGeom prst="rect">
-            <a:avLst/>
-          </a:prstGeom>
-          <a:solidFill>
-            <a:srgbClr val="149966"/>
-          </a:solidFill>
-          <a:ln w="12700">
-            <a:solidFill>
-              <a:srgbClr val="149966"/>
-            </a:solidFill>
-            <a:prstDash val="solid"/>
-          </a:ln>
-        </p:spPr>
-        <p:txBody>
-          <a:bodyPr/>
-          <a:lstStyle/>
-          <a:p>
-            <a:endParaRPr lang="en-US"/>
-          </a:p>
-        </p:txBody>
-      </p:sp>
-      <p:sp>
-        <p:nvSpPr>
-          <p:cNvPr id="6" name="Text 4"/>
-          <p:cNvSpPr/>
-          <p:nvPr/>
-        </p:nvSpPr>
-        <p:spPr>
-          <a:xfrm>
-            <a:off x="612648" y="1243584"/>
-            <a:ext cx="10789920" cy="384048"/>
-          </a:xfrm>
-          <a:prstGeom prst="rect">
-            <a:avLst/>
-          </a:prstGeom>
-          <a:noFill/>
-          <a:ln/>
-        </p:spPr>
-        <p:txBody>
-          <a:bodyPr wrap="square" lIns="0" tIns="0" rIns="0" bIns="0" rtlCol="0" anchor="ctr">
-            <a:normAutofit/>
-          </a:bodyPr>
-          <a:lstStyle/>
-          <a:p>
-            <a:pPr marL="0" indent="0">
-              <a:buNone/>
-            </a:pPr>
-            <a:r>
-              <a:rPr lang="en-US" sz="1500" dirty="0">
-                <a:solidFill>
-                  <a:srgbClr val="576173"/>
-                </a:solidFill>
-                <a:latin typeface="Aptos" pitchFamily="34" charset="0"/>
-                <a:ea typeface="Aptos" pitchFamily="34" charset="-122"/>
-                <a:cs typeface="Aptos" pitchFamily="34" charset="-120"/>
-              </a:rPr>
-              <a:t>Expert content becomes organized, retrievable working context—not an enormous prompt</a:t>
-            </a:r>
-            <a:endParaRPr lang="en-US" sz="1500" dirty="0"/>
-          </a:p>
-        </p:txBody>
-      </p:sp>
-      <p:sp>
-        <p:nvSpPr>
-          <p:cNvPr id="8" name="Shape 6">
-            <a:extLst>
-              <a:ext uri="{C183D7F6-B498-43B3-948B-1728B52AA6E4}">
-                <adec:decorative xmlns:adec="http://schemas.microsoft.com/office/drawing/2017/decorative" val="1"/>
-              </a:ext>
-            </a:extLst>
-          </p:cNvPr>
-          <p:cNvSpPr/>
-          <p:nvPr/>
-        </p:nvSpPr>
-        <p:spPr>
-          <a:xfrm>
-            <a:off x="868680" y="4892040"/>
-            <a:ext cx="2423160" cy="1325880"/>
-          </a:xfrm>
-          <a:prstGeom prst="roundRect">
-            <a:avLst>
-              <a:gd name="adj" fmla="val 8000"/>
-            </a:avLst>
-          </a:prstGeom>
-          <a:solidFill>
-            <a:srgbClr val="F5F6F8"/>
-          </a:solidFill>
-          <a:ln w="12700">
-            <a:solidFill>
-              <a:srgbClr val="D8DCE4"/>
-            </a:solidFill>
-            <a:prstDash val="solid"/>
-          </a:ln>
-        </p:spPr>
-        <p:txBody>
-          <a:bodyPr/>
-          <a:lstStyle/>
-          <a:p>
-            <a:endParaRPr lang="en-US"/>
-          </a:p>
-        </p:txBody>
-      </p:sp>
-      <p:sp>
-        <p:nvSpPr>
-          <p:cNvPr id="9" name="Shape 7">
-            <a:extLst>
-              <a:ext uri="{C183D7F6-B498-43B3-948B-1728B52AA6E4}">
-                <adec:decorative xmlns:adec="http://schemas.microsoft.com/office/drawing/2017/decorative" val="1"/>
-              </a:ext>
-            </a:extLst>
-          </p:cNvPr>
-          <p:cNvSpPr/>
-          <p:nvPr/>
-        </p:nvSpPr>
-        <p:spPr>
-          <a:xfrm>
-            <a:off x="1033272" y="5056632"/>
-            <a:ext cx="438912" cy="438912"/>
-          </a:xfrm>
-          <a:prstGeom prst="ellipse">
-            <a:avLst/>
-          </a:prstGeom>
-          <a:solidFill>
-            <a:srgbClr val="576173"/>
-          </a:solidFill>
-          <a:ln w="12700">
-            <a:solidFill>
-              <a:srgbClr val="576173"/>
-            </a:solidFill>
-            <a:prstDash val="solid"/>
-          </a:ln>
-        </p:spPr>
-        <p:txBody>
-          <a:bodyPr/>
-          <a:lstStyle/>
-          <a:p>
-            <a:endParaRPr lang="en-US"/>
-          </a:p>
-        </p:txBody>
-      </p:sp>
-      <p:sp>
-        <p:nvSpPr>
-          <p:cNvPr id="10" name="Text 8"/>
-          <p:cNvSpPr/>
-          <p:nvPr/>
-        </p:nvSpPr>
-        <p:spPr>
-          <a:xfrm>
-            <a:off x="1033272" y="5056632"/>
-            <a:ext cx="438912" cy="438912"/>
-          </a:xfrm>
-          <a:prstGeom prst="rect">
-            <a:avLst/>
-          </a:prstGeom>
-          <a:noFill/>
-          <a:ln/>
-        </p:spPr>
-        <p:txBody>
-          <a:bodyPr wrap="square" lIns="0" tIns="0" rIns="0" bIns="0" rtlCol="0" anchor="ctr">
-            <a:normAutofit/>
-          </a:bodyPr>
-          <a:lstStyle/>
-          <a:p>
-            <a:pPr marL="0" indent="0" algn="ctr">
-              <a:buNone/>
-            </a:pPr>
-            <a:r>
-              <a:rPr lang="en-US" sz="1000" b="1" dirty="0">
-                <a:solidFill>
-                  <a:srgbClr val="FFFFFF"/>
-                </a:solidFill>
-                <a:latin typeface="Aptos" pitchFamily="34" charset="0"/>
-                <a:ea typeface="Aptos" pitchFamily="34" charset="-122"/>
-                <a:cs typeface="Aptos" pitchFamily="34" charset="-120"/>
-              </a:rPr>
-              <a:t>1</a:t>
-            </a:r>
-            <a:endParaRPr lang="en-US" sz="1000" dirty="0"/>
-          </a:p>
-        </p:txBody>
-      </p:sp>
-      <p:sp>
-        <p:nvSpPr>
-          <p:cNvPr id="11" name="Text 9"/>
-          <p:cNvSpPr/>
-          <p:nvPr/>
-        </p:nvSpPr>
-        <p:spPr>
-          <a:xfrm>
-            <a:off x="1051560" y="5678424"/>
-            <a:ext cx="2057400" cy="365760"/>
-          </a:xfrm>
-          <a:prstGeom prst="rect">
-            <a:avLst/>
-          </a:prstGeom>
-          <a:noFill/>
-          <a:ln/>
-        </p:spPr>
-        <p:txBody>
-          <a:bodyPr wrap="square" lIns="0" tIns="0" rIns="0" bIns="0" rtlCol="0" anchor="ctr">
-            <a:normAutofit/>
-          </a:bodyPr>
-          <a:lstStyle/>
-          <a:p>
-            <a:pPr marL="0" indent="0" algn="ctr">
-              <a:buNone/>
-            </a:pPr>
-            <a:r>
-              <a:rPr lang="en-US" sz="1100" b="1" dirty="0">
-                <a:solidFill>
-                  <a:srgbClr val="17254E"/>
-                </a:solidFill>
-                <a:latin typeface="Aptos" pitchFamily="34" charset="0"/>
-                <a:ea typeface="Aptos" pitchFamily="34" charset="-122"/>
-                <a:cs typeface="Aptos" pitchFamily="34" charset="-120"/>
-              </a:rPr>
-              <a:t>PROMPT ONLY</a:t>
-            </a:r>
-            <a:endParaRPr lang="en-US" sz="1100" dirty="0"/>
-          </a:p>
-        </p:txBody>
-      </p:sp>
-      <p:sp>
-        <p:nvSpPr>
-          <p:cNvPr id="13" name="Shape 11">
-            <a:extLst>
-              <a:ext uri="{C183D7F6-B498-43B3-948B-1728B52AA6E4}">
-                <adec:decorative xmlns:adec="http://schemas.microsoft.com/office/drawing/2017/decorative" val="1"/>
-              </a:ext>
-            </a:extLst>
-          </p:cNvPr>
-          <p:cNvSpPr/>
-          <p:nvPr/>
-        </p:nvSpPr>
-        <p:spPr>
-          <a:xfrm>
-            <a:off x="3630168" y="4178808"/>
-            <a:ext cx="2423160" cy="2039112"/>
-          </a:xfrm>
-          <a:prstGeom prst="roundRect">
-            <a:avLst>
-              <a:gd name="adj" fmla="val 4494"/>
-            </a:avLst>
-          </a:prstGeom>
-          <a:solidFill>
-            <a:srgbClr val="F4EEDD"/>
-          </a:solidFill>
-          <a:ln w="12700">
-            <a:solidFill>
-              <a:srgbClr val="D8DCE4"/>
-            </a:solidFill>
-            <a:prstDash val="solid"/>
-          </a:ln>
-        </p:spPr>
-        <p:txBody>
-          <a:bodyPr/>
-          <a:lstStyle/>
-          <a:p>
-            <a:endParaRPr lang="en-US"/>
-          </a:p>
-        </p:txBody>
-      </p:sp>
-      <p:sp>
-        <p:nvSpPr>
-          <p:cNvPr id="14" name="Shape 12">
-            <a:extLst>
-              <a:ext uri="{C183D7F6-B498-43B3-948B-1728B52AA6E4}">
-                <adec:decorative xmlns:adec="http://schemas.microsoft.com/office/drawing/2017/decorative" val="1"/>
-              </a:ext>
-            </a:extLst>
-          </p:cNvPr>
-          <p:cNvSpPr/>
-          <p:nvPr/>
-        </p:nvSpPr>
-        <p:spPr>
-          <a:xfrm>
-            <a:off x="3794760" y="4343400"/>
-            <a:ext cx="438912" cy="438912"/>
-          </a:xfrm>
-          <a:prstGeom prst="ellipse">
-            <a:avLst/>
-          </a:prstGeom>
-          <a:solidFill>
-            <a:srgbClr val="17254E"/>
-          </a:solidFill>
-          <a:ln w="12700">
-            <a:solidFill>
-              <a:srgbClr val="17254E"/>
-            </a:solidFill>
-            <a:prstDash val="solid"/>
-          </a:ln>
-        </p:spPr>
-        <p:txBody>
-          <a:bodyPr/>
-          <a:lstStyle/>
-          <a:p>
-            <a:endParaRPr lang="en-US"/>
-          </a:p>
-        </p:txBody>
-      </p:sp>
-      <p:sp>
-        <p:nvSpPr>
-          <p:cNvPr id="15" name="Text 13"/>
-          <p:cNvSpPr/>
-          <p:nvPr/>
-        </p:nvSpPr>
-        <p:spPr>
-          <a:xfrm>
-            <a:off x="3794760" y="4343400"/>
-            <a:ext cx="438912" cy="438912"/>
-          </a:xfrm>
-          <a:prstGeom prst="rect">
-            <a:avLst/>
-          </a:prstGeom>
-          <a:noFill/>
-          <a:ln/>
-        </p:spPr>
-        <p:txBody>
-          <a:bodyPr wrap="square" lIns="0" tIns="0" rIns="0" bIns="0" rtlCol="0" anchor="ctr">
-            <a:normAutofit/>
-          </a:bodyPr>
-          <a:lstStyle/>
-          <a:p>
-            <a:pPr marL="0" indent="0" algn="ctr">
-              <a:buNone/>
-            </a:pPr>
-            <a:r>
-              <a:rPr lang="en-US" sz="1000" b="1" dirty="0">
-                <a:solidFill>
-                  <a:srgbClr val="FFFFFF"/>
-                </a:solidFill>
-                <a:latin typeface="Aptos" pitchFamily="34" charset="0"/>
-                <a:ea typeface="Aptos" pitchFamily="34" charset="-122"/>
-                <a:cs typeface="Aptos" pitchFamily="34" charset="-120"/>
-              </a:rPr>
-              <a:t>2</a:t>
-            </a:r>
-            <a:endParaRPr lang="en-US" sz="1000" dirty="0"/>
-          </a:p>
-        </p:txBody>
-      </p:sp>
-      <p:sp>
-        <p:nvSpPr>
-          <p:cNvPr id="16" name="Text 14"/>
-          <p:cNvSpPr/>
-          <p:nvPr/>
-        </p:nvSpPr>
-        <p:spPr>
-          <a:xfrm>
-            <a:off x="3813048" y="4965192"/>
-            <a:ext cx="2057400" cy="365760"/>
-          </a:xfrm>
-          <a:prstGeom prst="rect">
-            <a:avLst/>
-          </a:prstGeom>
-          <a:noFill/>
-          <a:ln/>
-        </p:spPr>
-        <p:txBody>
-          <a:bodyPr wrap="square" lIns="0" tIns="0" rIns="0" bIns="0" rtlCol="0" anchor="ctr">
-            <a:normAutofit/>
-          </a:bodyPr>
-          <a:lstStyle/>
-          <a:p>
-            <a:pPr marL="0" indent="0" algn="ctr">
-              <a:buNone/>
-            </a:pPr>
-            <a:r>
-              <a:rPr lang="en-US" sz="1100" b="1" dirty="0">
-                <a:solidFill>
-                  <a:srgbClr val="17254E"/>
-                </a:solidFill>
-                <a:latin typeface="Aptos" pitchFamily="34" charset="0"/>
-                <a:ea typeface="Aptos" pitchFamily="34" charset="-122"/>
-                <a:cs typeface="Aptos" pitchFamily="34" charset="-120"/>
-              </a:rPr>
-              <a:t>+ PROJECT MATERIALS</a:t>
-            </a:r>
-            <a:endParaRPr lang="en-US" sz="1100" dirty="0"/>
-          </a:p>
-        </p:txBody>
-      </p:sp>
-      <p:sp>
-        <p:nvSpPr>
-          <p:cNvPr id="17" name="Text 15"/>
-          <p:cNvSpPr/>
-          <p:nvPr/>
-        </p:nvSpPr>
-        <p:spPr>
-          <a:xfrm>
-            <a:off x="3858768" y="5440680"/>
-            <a:ext cx="1965960" cy="502920"/>
-          </a:xfrm>
-          <a:prstGeom prst="rect">
-            <a:avLst/>
-          </a:prstGeom>
-          <a:noFill/>
-          <a:ln/>
-        </p:spPr>
-        <p:txBody>
-          <a:bodyPr wrap="square" lIns="0" tIns="0" rIns="0" bIns="0" rtlCol="0" anchor="t">
-            <a:normAutofit/>
-          </a:bodyPr>
-          <a:lstStyle/>
-          <a:p>
-            <a:pPr marL="0" indent="0" algn="ctr">
-              <a:buNone/>
-            </a:pPr>
-            <a:r>
-              <a:rPr lang="en-US" sz="1100" dirty="0">
-                <a:solidFill>
-                  <a:srgbClr val="202532"/>
-                </a:solidFill>
-                <a:latin typeface="Aptos" pitchFamily="34" charset="0"/>
-                <a:ea typeface="Aptos" pitchFamily="34" charset="-122"/>
-                <a:cs typeface="Aptos" pitchFamily="34" charset="-120"/>
-              </a:rPr>
-              <a:t>Uploads, course documents, local folders, examples, images, and data</a:t>
-            </a:r>
-            <a:endParaRPr lang="en-US" sz="1100" dirty="0"/>
-          </a:p>
-        </p:txBody>
-      </p:sp>
-      <p:sp>
-        <p:nvSpPr>
-          <p:cNvPr id="18" name="Shape 16">
-            <a:extLst>
-              <a:ext uri="{C183D7F6-B498-43B3-948B-1728B52AA6E4}">
-                <adec:decorative xmlns:adec="http://schemas.microsoft.com/office/drawing/2017/decorative" val="1"/>
-              </a:ext>
-            </a:extLst>
-          </p:cNvPr>
-          <p:cNvSpPr/>
-          <p:nvPr/>
-        </p:nvSpPr>
-        <p:spPr>
-          <a:xfrm>
-            <a:off x="6391656" y="3465576"/>
-            <a:ext cx="2423160" cy="2752344"/>
-          </a:xfrm>
-          <a:prstGeom prst="roundRect">
-            <a:avLst>
-              <a:gd name="adj" fmla="val 3125"/>
-            </a:avLst>
-          </a:prstGeom>
-          <a:solidFill>
-            <a:srgbClr val="E7F4EE"/>
-          </a:solidFill>
-          <a:ln w="12700">
-            <a:solidFill>
-              <a:srgbClr val="D8DCE4"/>
-            </a:solidFill>
-            <a:prstDash val="solid"/>
-          </a:ln>
-        </p:spPr>
-        <p:txBody>
-          <a:bodyPr/>
-          <a:lstStyle/>
-          <a:p>
-            <a:endParaRPr lang="en-US"/>
-          </a:p>
-        </p:txBody>
-      </p:sp>
-      <p:sp>
-        <p:nvSpPr>
-          <p:cNvPr id="19" name="Shape 17">
-            <a:extLst>
-              <a:ext uri="{C183D7F6-B498-43B3-948B-1728B52AA6E4}">
-                <adec:decorative xmlns:adec="http://schemas.microsoft.com/office/drawing/2017/decorative" val="1"/>
-              </a:ext>
-            </a:extLst>
-          </p:cNvPr>
-          <p:cNvSpPr/>
-          <p:nvPr/>
-        </p:nvSpPr>
-        <p:spPr>
-          <a:xfrm>
-            <a:off x="6556248" y="3630168"/>
-            <a:ext cx="438912" cy="438912"/>
-          </a:xfrm>
-          <a:prstGeom prst="ellipse">
-            <a:avLst/>
-          </a:prstGeom>
-          <a:solidFill>
-            <a:srgbClr val="0B7049"/>
-          </a:solidFill>
-          <a:ln w="12700">
-            <a:solidFill>
-              <a:srgbClr val="0B7049"/>
-            </a:solidFill>
-            <a:prstDash val="solid"/>
-          </a:ln>
-        </p:spPr>
-        <p:txBody>
-          <a:bodyPr/>
-          <a:lstStyle/>
-          <a:p>
-            <a:endParaRPr lang="en-US"/>
-          </a:p>
-        </p:txBody>
-      </p:sp>
-      <p:sp>
-        <p:nvSpPr>
-          <p:cNvPr id="20" name="Text 18"/>
-          <p:cNvSpPr/>
-          <p:nvPr/>
-        </p:nvSpPr>
-        <p:spPr>
-          <a:xfrm>
-            <a:off x="6556248" y="3630168"/>
-            <a:ext cx="438912" cy="438912"/>
-          </a:xfrm>
-          <a:prstGeom prst="rect">
-            <a:avLst/>
-          </a:prstGeom>
-          <a:noFill/>
-          <a:ln/>
-        </p:spPr>
-        <p:txBody>
-          <a:bodyPr wrap="square" lIns="0" tIns="0" rIns="0" bIns="0" rtlCol="0" anchor="ctr">
-            <a:normAutofit/>
-          </a:bodyPr>
-          <a:lstStyle/>
-          <a:p>
-            <a:pPr marL="0" indent="0" algn="ctr">
-              <a:buNone/>
-            </a:pPr>
-            <a:r>
-              <a:rPr lang="en-US" sz="1000" b="1" dirty="0">
-                <a:solidFill>
-                  <a:srgbClr val="FFFFFF"/>
-                </a:solidFill>
-                <a:latin typeface="Aptos" pitchFamily="34" charset="0"/>
-                <a:ea typeface="Aptos" pitchFamily="34" charset="-122"/>
-                <a:cs typeface="Aptos" pitchFamily="34" charset="-120"/>
-              </a:rPr>
-              <a:t>3</a:t>
-            </a:r>
-            <a:endParaRPr lang="en-US" sz="1000" dirty="0"/>
-          </a:p>
-        </p:txBody>
-      </p:sp>
-      <p:sp>
-        <p:nvSpPr>
-          <p:cNvPr id="21" name="Text 19"/>
-          <p:cNvSpPr/>
-          <p:nvPr/>
-        </p:nvSpPr>
-        <p:spPr>
-          <a:xfrm>
-            <a:off x="6574536" y="4251960"/>
-            <a:ext cx="2057400" cy="365760"/>
-          </a:xfrm>
-          <a:prstGeom prst="rect">
-            <a:avLst/>
-          </a:prstGeom>
-          <a:noFill/>
-          <a:ln/>
-        </p:spPr>
-        <p:txBody>
-          <a:bodyPr wrap="square" lIns="0" tIns="0" rIns="0" bIns="0" rtlCol="0" anchor="ctr">
-            <a:normAutofit/>
-          </a:bodyPr>
-          <a:lstStyle/>
-          <a:p>
-            <a:pPr marL="0" indent="0" algn="ctr">
-              <a:buNone/>
-            </a:pPr>
-            <a:r>
-              <a:rPr lang="en-US" sz="1100" b="1" dirty="0">
-                <a:solidFill>
-                  <a:srgbClr val="17254E"/>
-                </a:solidFill>
-                <a:latin typeface="Aptos" pitchFamily="34" charset="0"/>
-                <a:ea typeface="Aptos" pitchFamily="34" charset="-122"/>
-                <a:cs typeface="Aptos" pitchFamily="34" charset="-120"/>
-              </a:rPr>
-              <a:t>+ PROJECT MEMORY</a:t>
-            </a:r>
-            <a:endParaRPr lang="en-US" sz="1100" dirty="0"/>
-          </a:p>
-        </p:txBody>
-      </p:sp>
-      <p:sp>
-        <p:nvSpPr>
-          <p:cNvPr id="22" name="Text 20"/>
-          <p:cNvSpPr/>
-          <p:nvPr/>
-        </p:nvSpPr>
-        <p:spPr>
-          <a:xfrm>
-            <a:off x="6620256" y="4727448"/>
-            <a:ext cx="1965960" cy="896112"/>
-          </a:xfrm>
-          <a:prstGeom prst="rect">
-            <a:avLst/>
-          </a:prstGeom>
-          <a:noFill/>
-          <a:ln/>
-        </p:spPr>
-        <p:txBody>
-          <a:bodyPr wrap="square" lIns="0" tIns="0" rIns="0" bIns="0" rtlCol="0" anchor="t">
-            <a:normAutofit/>
-          </a:bodyPr>
-          <a:lstStyle/>
-          <a:p>
-            <a:pPr marL="0" indent="0" algn="ctr">
-              <a:buNone/>
-            </a:pPr>
-            <a:r>
-              <a:rPr lang="en-US" sz="1100" dirty="0">
-                <a:solidFill>
-                  <a:srgbClr val="202532"/>
-                </a:solidFill>
-                <a:latin typeface="Aptos" pitchFamily="34" charset="0"/>
-                <a:ea typeface="Aptos" pitchFamily="34" charset="-122"/>
-                <a:cs typeface="Aptos" pitchFamily="34" charset="-120"/>
-              </a:rPr>
-              <a:t>Design records, previous prompts, archived iterations, and verified decisions</a:t>
-            </a:r>
-            <a:endParaRPr lang="en-US" sz="1100" dirty="0"/>
-          </a:p>
-        </p:txBody>
-      </p:sp>
-      <p:sp>
-        <p:nvSpPr>
-          <p:cNvPr id="23" name="Shape 21">
-            <a:extLst>
-              <a:ext uri="{C183D7F6-B498-43B3-948B-1728B52AA6E4}">
-                <adec:decorative xmlns:adec="http://schemas.microsoft.com/office/drawing/2017/decorative" val="1"/>
-              </a:ext>
-            </a:extLst>
-          </p:cNvPr>
-          <p:cNvSpPr/>
-          <p:nvPr/>
-        </p:nvSpPr>
-        <p:spPr>
-          <a:xfrm>
-            <a:off x="9153144" y="2752344"/>
-            <a:ext cx="2423160" cy="3465576"/>
-          </a:xfrm>
-          <a:prstGeom prst="roundRect">
-            <a:avLst>
-              <a:gd name="adj" fmla="val 3019"/>
-            </a:avLst>
-          </a:prstGeom>
-          <a:solidFill>
-            <a:srgbClr val="DDE7F6"/>
-          </a:solidFill>
-          <a:ln w="12700">
-            <a:solidFill>
-              <a:srgbClr val="D8DCE4"/>
-            </a:solidFill>
-            <a:prstDash val="solid"/>
-          </a:ln>
-        </p:spPr>
-        <p:txBody>
-          <a:bodyPr/>
-          <a:lstStyle/>
-          <a:p>
-            <a:endParaRPr lang="en-US"/>
-          </a:p>
-        </p:txBody>
-      </p:sp>
-      <p:sp>
-        <p:nvSpPr>
-          <p:cNvPr id="24" name="Shape 22">
-            <a:extLst>
-              <a:ext uri="{C183D7F6-B498-43B3-948B-1728B52AA6E4}">
-                <adec:decorative xmlns:adec="http://schemas.microsoft.com/office/drawing/2017/decorative" val="1"/>
-              </a:ext>
-            </a:extLst>
-          </p:cNvPr>
-          <p:cNvSpPr/>
-          <p:nvPr/>
-        </p:nvSpPr>
-        <p:spPr>
-          <a:xfrm>
-            <a:off x="9317736" y="2916936"/>
-            <a:ext cx="438912" cy="438912"/>
-          </a:xfrm>
-          <a:prstGeom prst="ellipse">
-            <a:avLst/>
-          </a:prstGeom>
-          <a:solidFill>
-            <a:srgbClr val="40547F"/>
-          </a:solidFill>
-          <a:ln w="12700">
-            <a:solidFill>
-              <a:srgbClr val="40547F"/>
-            </a:solidFill>
-            <a:prstDash val="solid"/>
-          </a:ln>
-        </p:spPr>
-        <p:txBody>
-          <a:bodyPr/>
-          <a:lstStyle/>
-          <a:p>
-            <a:endParaRPr lang="en-US"/>
-          </a:p>
-        </p:txBody>
-      </p:sp>
-      <p:sp>
-        <p:nvSpPr>
-          <p:cNvPr id="25" name="Text 23"/>
-          <p:cNvSpPr/>
-          <p:nvPr/>
-        </p:nvSpPr>
-        <p:spPr>
-          <a:xfrm>
-            <a:off x="9317736" y="2916936"/>
-            <a:ext cx="438912" cy="438912"/>
-          </a:xfrm>
-          <a:prstGeom prst="rect">
-            <a:avLst/>
-          </a:prstGeom>
-          <a:noFill/>
-          <a:ln/>
-        </p:spPr>
-        <p:txBody>
-          <a:bodyPr wrap="square" lIns="0" tIns="0" rIns="0" bIns="0" rtlCol="0" anchor="ctr">
-            <a:normAutofit/>
-          </a:bodyPr>
-          <a:lstStyle/>
-          <a:p>
-            <a:pPr marL="0" indent="0" algn="ctr">
-              <a:buNone/>
-            </a:pPr>
-            <a:r>
-              <a:rPr lang="en-US" sz="1000" b="1" dirty="0">
-                <a:solidFill>
-                  <a:srgbClr val="FFFFFF"/>
-                </a:solidFill>
-                <a:latin typeface="Aptos" pitchFamily="34" charset="0"/>
-                <a:ea typeface="Aptos" pitchFamily="34" charset="-122"/>
-                <a:cs typeface="Aptos" pitchFamily="34" charset="-120"/>
-              </a:rPr>
-              <a:t>4</a:t>
-            </a:r>
-            <a:endParaRPr lang="en-US" sz="1000" dirty="0"/>
-          </a:p>
-        </p:txBody>
-      </p:sp>
-      <p:sp>
-        <p:nvSpPr>
-          <p:cNvPr id="26" name="Text 24"/>
-          <p:cNvSpPr/>
-          <p:nvPr/>
-        </p:nvSpPr>
-        <p:spPr>
-          <a:xfrm>
-            <a:off x="9336024" y="3538728"/>
-            <a:ext cx="2057400" cy="365760"/>
-          </a:xfrm>
-          <a:prstGeom prst="rect">
-            <a:avLst/>
-          </a:prstGeom>
-          <a:noFill/>
-          <a:ln/>
-        </p:spPr>
-        <p:txBody>
-          <a:bodyPr wrap="square" lIns="0" tIns="0" rIns="0" bIns="0" rtlCol="0" anchor="ctr">
-            <a:normAutofit/>
-          </a:bodyPr>
-          <a:lstStyle/>
-          <a:p>
-            <a:pPr marL="0" indent="0" algn="ctr">
-              <a:buNone/>
-            </a:pPr>
-            <a:r>
-              <a:rPr lang="en-US" sz="1100" b="1" dirty="0">
-                <a:solidFill>
-                  <a:srgbClr val="17254E"/>
-                </a:solidFill>
-                <a:latin typeface="Aptos" pitchFamily="34" charset="0"/>
-                <a:ea typeface="Aptos" pitchFamily="34" charset="-122"/>
-                <a:cs typeface="Aptos" pitchFamily="34" charset="-120"/>
-              </a:rPr>
-              <a:t>+ CONNECTED SOURCES</a:t>
-            </a:r>
-            <a:endParaRPr lang="en-US" sz="1100" dirty="0"/>
-          </a:p>
-        </p:txBody>
-      </p:sp>
-      <p:sp>
-        <p:nvSpPr>
-          <p:cNvPr id="27" name="Text 25"/>
-          <p:cNvSpPr/>
-          <p:nvPr/>
-        </p:nvSpPr>
-        <p:spPr>
-          <a:xfrm>
-            <a:off x="9381744" y="4014216"/>
-            <a:ext cx="1965960" cy="1609344"/>
-          </a:xfrm>
-          <a:prstGeom prst="rect">
-            <a:avLst/>
-          </a:prstGeom>
-          <a:noFill/>
-          <a:ln/>
-        </p:spPr>
-        <p:txBody>
-          <a:bodyPr wrap="square" lIns="0" tIns="0" rIns="0" bIns="0" rtlCol="0" anchor="t">
-            <a:normAutofit/>
-          </a:bodyPr>
-          <a:lstStyle/>
-          <a:p>
-            <a:pPr marL="0" indent="0" algn="ctr">
-              <a:buNone/>
-            </a:pPr>
-            <a:r>
-              <a:rPr lang="en-US" sz="1100" dirty="0">
-                <a:solidFill>
-                  <a:srgbClr val="202532"/>
-                </a:solidFill>
-                <a:latin typeface="Aptos" pitchFamily="34" charset="0"/>
-                <a:ea typeface="Aptos" pitchFamily="34" charset="-122"/>
-                <a:cs typeface="Aptos" pitchFamily="34" charset="-120"/>
-              </a:rPr>
-              <a:t>Institutional resources, current sources, APIs, and search—when appropriate</a:t>
-            </a:r>
-            <a:endParaRPr lang="en-US" sz="1100" dirty="0"/>
-          </a:p>
-        </p:txBody>
-      </p:sp>
-      <p:sp>
-        <p:nvSpPr>
-          <p:cNvPr id="7" name="Text 5"/>
-          <p:cNvSpPr/>
-          <p:nvPr/>
-        </p:nvSpPr>
-        <p:spPr>
-          <a:xfrm>
-            <a:off x="594360" y="6510528"/>
-            <a:ext cx="5943600" cy="164592"/>
-          </a:xfrm>
-          <a:prstGeom prst="rect">
-            <a:avLst/>
-          </a:prstGeom>
-          <a:noFill/>
-          <a:ln/>
-        </p:spPr>
-        <p:txBody>
-          <a:bodyPr wrap="square" lIns="0" tIns="0" rIns="0" bIns="0" rtlCol="0" anchor="ctr">
-            <a:normAutofit/>
-          </a:bodyPr>
-          <a:lstStyle/>
-          <a:p>
-            <a:pPr marL="0" indent="0">
-              <a:buNone/>
-            </a:pPr>
-            <a:r>
-              <a:rPr lang="en-US" sz="800" dirty="0">
-                <a:solidFill>
-                  <a:srgbClr val="576173"/>
-                </a:solidFill>
-                <a:latin typeface="Aptos" pitchFamily="34" charset="0"/>
-                <a:ea typeface="Aptos" pitchFamily="34" charset="-122"/>
-                <a:cs typeface="Aptos" pitchFamily="34" charset="-120"/>
-              </a:rPr>
-              <a:t>Hillsborough College  |  Summer Institute 2026</a:t>
-            </a:r>
-            <a:endParaRPr lang="en-US" sz="800" dirty="0"/>
-          </a:p>
-        </p:txBody>
-      </p:sp>
-      <p:sp>
-        <p:nvSpPr>
           <p:cNvPr id="12" name="Shape 1">
             <a:extLst>
               <a:ext uri="{FF2B5EF4-FFF2-40B4-BE49-F238E27FC236}">
@@ -19534,6 +18754,889 @@
               <a:t>BRASS TACKS</a:t>
             </a:r>
             <a:endParaRPr lang="en-US" sz="900" dirty="0"/>
+          </a:p>
+        </p:txBody>
+      </p:sp>
+      <p:sp>
+        <p:nvSpPr>
+          <p:cNvPr id="2" name="Shape 0">
+            <a:extLst>
+              <a:ext uri="{C183D7F6-B498-43B3-948B-1728B52AA6E4}">
+                <adec:decorative xmlns:adec="http://schemas.microsoft.com/office/drawing/2017/decorative" val="1"/>
+              </a:ext>
+            </a:extLst>
+          </p:cNvPr>
+          <p:cNvSpPr/>
+          <p:nvPr/>
+        </p:nvSpPr>
+        <p:spPr>
+          <a:xfrm>
+            <a:off x="0" y="0"/>
+            <a:ext cx="146304" cy="6858000"/>
+          </a:xfrm>
+          <a:prstGeom prst="rect">
+            <a:avLst/>
+          </a:prstGeom>
+          <a:solidFill>
+            <a:srgbClr val="149966"/>
+          </a:solidFill>
+          <a:ln w="12700">
+            <a:solidFill>
+              <a:srgbClr val="149966"/>
+            </a:solidFill>
+            <a:prstDash val="solid"/>
+          </a:ln>
+        </p:spPr>
+        <p:txBody>
+          <a:bodyPr/>
+          <a:lstStyle/>
+          <a:p>
+            <a:endParaRPr lang="en-US"/>
+          </a:p>
+        </p:txBody>
+      </p:sp>
+      <p:sp>
+        <p:nvSpPr>
+          <p:cNvPr id="6" name="Text 4"/>
+          <p:cNvSpPr/>
+          <p:nvPr/>
+        </p:nvSpPr>
+        <p:spPr>
+          <a:xfrm>
+            <a:off x="612648" y="1243584"/>
+            <a:ext cx="10789920" cy="384048"/>
+          </a:xfrm>
+          <a:prstGeom prst="rect">
+            <a:avLst/>
+          </a:prstGeom>
+          <a:noFill/>
+          <a:ln/>
+        </p:spPr>
+        <p:txBody>
+          <a:bodyPr wrap="square" lIns="0" tIns="0" rIns="0" bIns="0" rtlCol="0" anchor="ctr">
+            <a:normAutofit/>
+          </a:bodyPr>
+          <a:lstStyle/>
+          <a:p>
+            <a:pPr marL="0" indent="0">
+              <a:buNone/>
+            </a:pPr>
+            <a:r>
+              <a:rPr lang="en-US" sz="1500" dirty="0">
+                <a:solidFill>
+                  <a:srgbClr val="576173"/>
+                </a:solidFill>
+                <a:latin typeface="Aptos" pitchFamily="34" charset="0"/>
+                <a:ea typeface="Aptos" pitchFamily="34" charset="-122"/>
+                <a:cs typeface="Aptos" pitchFamily="34" charset="-120"/>
+              </a:rPr>
+              <a:t>Expert content becomes organized, retrievable working context—not an enormous prompt</a:t>
+            </a:r>
+            <a:endParaRPr lang="en-US" sz="1500" dirty="0"/>
+          </a:p>
+        </p:txBody>
+      </p:sp>
+      <p:sp>
+        <p:nvSpPr>
+          <p:cNvPr id="8" name="Shape 6">
+            <a:extLst>
+              <a:ext uri="{C183D7F6-B498-43B3-948B-1728B52AA6E4}">
+                <adec:decorative xmlns:adec="http://schemas.microsoft.com/office/drawing/2017/decorative" val="1"/>
+              </a:ext>
+            </a:extLst>
+          </p:cNvPr>
+          <p:cNvSpPr/>
+          <p:nvPr/>
+        </p:nvSpPr>
+        <p:spPr>
+          <a:xfrm>
+            <a:off x="868680" y="4892040"/>
+            <a:ext cx="2423160" cy="1325880"/>
+          </a:xfrm>
+          <a:prstGeom prst="roundRect">
+            <a:avLst>
+              <a:gd name="adj" fmla="val 8000"/>
+            </a:avLst>
+          </a:prstGeom>
+          <a:solidFill>
+            <a:srgbClr val="F5F6F8"/>
+          </a:solidFill>
+          <a:ln w="12700">
+            <a:solidFill>
+              <a:srgbClr val="D8DCE4"/>
+            </a:solidFill>
+            <a:prstDash val="solid"/>
+          </a:ln>
+        </p:spPr>
+        <p:txBody>
+          <a:bodyPr/>
+          <a:lstStyle/>
+          <a:p>
+            <a:endParaRPr lang="en-US"/>
+          </a:p>
+        </p:txBody>
+      </p:sp>
+      <p:sp>
+        <p:nvSpPr>
+          <p:cNvPr id="9" name="Shape 7">
+            <a:extLst>
+              <a:ext uri="{C183D7F6-B498-43B3-948B-1728B52AA6E4}">
+                <adec:decorative xmlns:adec="http://schemas.microsoft.com/office/drawing/2017/decorative" val="1"/>
+              </a:ext>
+            </a:extLst>
+          </p:cNvPr>
+          <p:cNvSpPr/>
+          <p:nvPr/>
+        </p:nvSpPr>
+        <p:spPr>
+          <a:xfrm>
+            <a:off x="1033272" y="5056632"/>
+            <a:ext cx="438912" cy="438912"/>
+          </a:xfrm>
+          <a:prstGeom prst="ellipse">
+            <a:avLst/>
+          </a:prstGeom>
+          <a:solidFill>
+            <a:srgbClr val="576173"/>
+          </a:solidFill>
+          <a:ln w="12700">
+            <a:solidFill>
+              <a:srgbClr val="576173"/>
+            </a:solidFill>
+            <a:prstDash val="solid"/>
+          </a:ln>
+        </p:spPr>
+        <p:txBody>
+          <a:bodyPr/>
+          <a:lstStyle/>
+          <a:p>
+            <a:endParaRPr lang="en-US"/>
+          </a:p>
+        </p:txBody>
+      </p:sp>
+      <p:sp>
+        <p:nvSpPr>
+          <p:cNvPr id="10" name="Text 8"/>
+          <p:cNvSpPr/>
+          <p:nvPr/>
+        </p:nvSpPr>
+        <p:spPr>
+          <a:xfrm>
+            <a:off x="1033272" y="5056632"/>
+            <a:ext cx="438912" cy="438912"/>
+          </a:xfrm>
+          <a:prstGeom prst="rect">
+            <a:avLst/>
+          </a:prstGeom>
+          <a:noFill/>
+          <a:ln/>
+        </p:spPr>
+        <p:txBody>
+          <a:bodyPr wrap="square" lIns="0" tIns="0" rIns="0" bIns="0" rtlCol="0" anchor="ctr">
+            <a:normAutofit/>
+          </a:bodyPr>
+          <a:lstStyle/>
+          <a:p>
+            <a:pPr marL="0" indent="0" algn="ctr">
+              <a:buNone/>
+            </a:pPr>
+            <a:r>
+              <a:rPr lang="en-US" sz="1000" b="1" dirty="0">
+                <a:solidFill>
+                  <a:srgbClr val="FFFFFF"/>
+                </a:solidFill>
+                <a:latin typeface="Aptos" pitchFamily="34" charset="0"/>
+                <a:ea typeface="Aptos" pitchFamily="34" charset="-122"/>
+                <a:cs typeface="Aptos" pitchFamily="34" charset="-120"/>
+              </a:rPr>
+              <a:t>1</a:t>
+            </a:r>
+            <a:endParaRPr lang="en-US" sz="1000" dirty="0"/>
+          </a:p>
+        </p:txBody>
+      </p:sp>
+      <p:sp>
+        <p:nvSpPr>
+          <p:cNvPr id="11" name="Text 9"/>
+          <p:cNvSpPr/>
+          <p:nvPr/>
+        </p:nvSpPr>
+        <p:spPr>
+          <a:xfrm>
+            <a:off x="1051560" y="5678424"/>
+            <a:ext cx="2057400" cy="365760"/>
+          </a:xfrm>
+          <a:prstGeom prst="rect">
+            <a:avLst/>
+          </a:prstGeom>
+          <a:noFill/>
+          <a:ln/>
+        </p:spPr>
+        <p:txBody>
+          <a:bodyPr wrap="square" lIns="0" tIns="0" rIns="0" bIns="0" rtlCol="0" anchor="ctr">
+            <a:normAutofit/>
+          </a:bodyPr>
+          <a:lstStyle/>
+          <a:p>
+            <a:pPr marL="0" indent="0" algn="ctr">
+              <a:buNone/>
+            </a:pPr>
+            <a:r>
+              <a:rPr lang="en-US" sz="1100" b="1" dirty="0">
+                <a:solidFill>
+                  <a:srgbClr val="17254E"/>
+                </a:solidFill>
+                <a:latin typeface="Aptos" pitchFamily="34" charset="0"/>
+                <a:ea typeface="Aptos" pitchFamily="34" charset="-122"/>
+                <a:cs typeface="Aptos" pitchFamily="34" charset="-120"/>
+              </a:rPr>
+              <a:t>PROMPT ONLY</a:t>
+            </a:r>
+            <a:endParaRPr lang="en-US" sz="1100" dirty="0"/>
+          </a:p>
+        </p:txBody>
+      </p:sp>
+      <p:sp>
+        <p:nvSpPr>
+          <p:cNvPr id="13" name="Shape 11">
+            <a:extLst>
+              <a:ext uri="{C183D7F6-B498-43B3-948B-1728B52AA6E4}">
+                <adec:decorative xmlns:adec="http://schemas.microsoft.com/office/drawing/2017/decorative" val="1"/>
+              </a:ext>
+            </a:extLst>
+          </p:cNvPr>
+          <p:cNvSpPr/>
+          <p:nvPr/>
+        </p:nvSpPr>
+        <p:spPr>
+          <a:xfrm>
+            <a:off x="3630168" y="4178808"/>
+            <a:ext cx="2423160" cy="2039112"/>
+          </a:xfrm>
+          <a:prstGeom prst="roundRect">
+            <a:avLst>
+              <a:gd name="adj" fmla="val 4494"/>
+            </a:avLst>
+          </a:prstGeom>
+          <a:solidFill>
+            <a:srgbClr val="F4EEDD"/>
+          </a:solidFill>
+          <a:ln w="12700">
+            <a:solidFill>
+              <a:srgbClr val="D8DCE4"/>
+            </a:solidFill>
+            <a:prstDash val="solid"/>
+          </a:ln>
+        </p:spPr>
+        <p:txBody>
+          <a:bodyPr/>
+          <a:lstStyle/>
+          <a:p>
+            <a:endParaRPr lang="en-US"/>
+          </a:p>
+        </p:txBody>
+      </p:sp>
+      <p:sp>
+        <p:nvSpPr>
+          <p:cNvPr id="14" name="Shape 12">
+            <a:extLst>
+              <a:ext uri="{C183D7F6-B498-43B3-948B-1728B52AA6E4}">
+                <adec:decorative xmlns:adec="http://schemas.microsoft.com/office/drawing/2017/decorative" val="1"/>
+              </a:ext>
+            </a:extLst>
+          </p:cNvPr>
+          <p:cNvSpPr/>
+          <p:nvPr/>
+        </p:nvSpPr>
+        <p:spPr>
+          <a:xfrm>
+            <a:off x="3794760" y="4343400"/>
+            <a:ext cx="438912" cy="438912"/>
+          </a:xfrm>
+          <a:prstGeom prst="ellipse">
+            <a:avLst/>
+          </a:prstGeom>
+          <a:solidFill>
+            <a:srgbClr val="17254E"/>
+          </a:solidFill>
+          <a:ln w="12700">
+            <a:solidFill>
+              <a:srgbClr val="17254E"/>
+            </a:solidFill>
+            <a:prstDash val="solid"/>
+          </a:ln>
+        </p:spPr>
+        <p:txBody>
+          <a:bodyPr/>
+          <a:lstStyle/>
+          <a:p>
+            <a:endParaRPr lang="en-US"/>
+          </a:p>
+        </p:txBody>
+      </p:sp>
+      <p:sp>
+        <p:nvSpPr>
+          <p:cNvPr id="15" name="Text 13"/>
+          <p:cNvSpPr/>
+          <p:nvPr/>
+        </p:nvSpPr>
+        <p:spPr>
+          <a:xfrm>
+            <a:off x="3794760" y="4343400"/>
+            <a:ext cx="438912" cy="438912"/>
+          </a:xfrm>
+          <a:prstGeom prst="rect">
+            <a:avLst/>
+          </a:prstGeom>
+          <a:noFill/>
+          <a:ln/>
+        </p:spPr>
+        <p:txBody>
+          <a:bodyPr wrap="square" lIns="0" tIns="0" rIns="0" bIns="0" rtlCol="0" anchor="ctr">
+            <a:normAutofit/>
+          </a:bodyPr>
+          <a:lstStyle/>
+          <a:p>
+            <a:pPr marL="0" indent="0" algn="ctr">
+              <a:buNone/>
+            </a:pPr>
+            <a:r>
+              <a:rPr lang="en-US" sz="1000" b="1" dirty="0">
+                <a:solidFill>
+                  <a:srgbClr val="FFFFFF"/>
+                </a:solidFill>
+                <a:latin typeface="Aptos" pitchFamily="34" charset="0"/>
+                <a:ea typeface="Aptos" pitchFamily="34" charset="-122"/>
+                <a:cs typeface="Aptos" pitchFamily="34" charset="-120"/>
+              </a:rPr>
+              <a:t>2</a:t>
+            </a:r>
+            <a:endParaRPr lang="en-US" sz="1000" dirty="0"/>
+          </a:p>
+        </p:txBody>
+      </p:sp>
+      <p:sp>
+        <p:nvSpPr>
+          <p:cNvPr id="16" name="Text 14"/>
+          <p:cNvSpPr/>
+          <p:nvPr/>
+        </p:nvSpPr>
+        <p:spPr>
+          <a:xfrm>
+            <a:off x="3813048" y="4965192"/>
+            <a:ext cx="2057400" cy="365760"/>
+          </a:xfrm>
+          <a:prstGeom prst="rect">
+            <a:avLst/>
+          </a:prstGeom>
+          <a:noFill/>
+          <a:ln/>
+        </p:spPr>
+        <p:txBody>
+          <a:bodyPr wrap="square" lIns="0" tIns="0" rIns="0" bIns="0" rtlCol="0" anchor="ctr">
+            <a:normAutofit/>
+          </a:bodyPr>
+          <a:lstStyle/>
+          <a:p>
+            <a:pPr marL="0" indent="0" algn="ctr">
+              <a:buNone/>
+            </a:pPr>
+            <a:r>
+              <a:rPr lang="en-US" sz="1100" b="1" dirty="0">
+                <a:solidFill>
+                  <a:srgbClr val="17254E"/>
+                </a:solidFill>
+                <a:latin typeface="Aptos" pitchFamily="34" charset="0"/>
+                <a:ea typeface="Aptos" pitchFamily="34" charset="-122"/>
+                <a:cs typeface="Aptos" pitchFamily="34" charset="-120"/>
+              </a:rPr>
+              <a:t>+ PROJECT MATERIALS</a:t>
+            </a:r>
+            <a:endParaRPr lang="en-US" sz="1100" dirty="0"/>
+          </a:p>
+        </p:txBody>
+      </p:sp>
+      <p:sp>
+        <p:nvSpPr>
+          <p:cNvPr id="17" name="Text 15"/>
+          <p:cNvSpPr/>
+          <p:nvPr/>
+        </p:nvSpPr>
+        <p:spPr>
+          <a:xfrm>
+            <a:off x="3858768" y="5440680"/>
+            <a:ext cx="1965960" cy="502920"/>
+          </a:xfrm>
+          <a:prstGeom prst="rect">
+            <a:avLst/>
+          </a:prstGeom>
+          <a:noFill/>
+          <a:ln/>
+        </p:spPr>
+        <p:txBody>
+          <a:bodyPr wrap="square" lIns="0" tIns="0" rIns="0" bIns="0" rtlCol="0" anchor="t">
+            <a:normAutofit/>
+          </a:bodyPr>
+          <a:lstStyle/>
+          <a:p>
+            <a:pPr marL="0" indent="0" algn="ctr">
+              <a:buNone/>
+            </a:pPr>
+            <a:r>
+              <a:rPr lang="en-US" sz="1100" dirty="0">
+                <a:solidFill>
+                  <a:srgbClr val="202532"/>
+                </a:solidFill>
+                <a:latin typeface="Aptos" pitchFamily="34" charset="0"/>
+                <a:ea typeface="Aptos" pitchFamily="34" charset="-122"/>
+                <a:cs typeface="Aptos" pitchFamily="34" charset="-120"/>
+              </a:rPr>
+              <a:t>Uploads, course documents, local folders, examples, images, and data</a:t>
+            </a:r>
+            <a:endParaRPr lang="en-US" sz="1100" dirty="0"/>
+          </a:p>
+        </p:txBody>
+      </p:sp>
+      <p:sp>
+        <p:nvSpPr>
+          <p:cNvPr id="18" name="Shape 16">
+            <a:extLst>
+              <a:ext uri="{C183D7F6-B498-43B3-948B-1728B52AA6E4}">
+                <adec:decorative xmlns:adec="http://schemas.microsoft.com/office/drawing/2017/decorative" val="1"/>
+              </a:ext>
+            </a:extLst>
+          </p:cNvPr>
+          <p:cNvSpPr/>
+          <p:nvPr/>
+        </p:nvSpPr>
+        <p:spPr>
+          <a:xfrm>
+            <a:off x="6391656" y="3465576"/>
+            <a:ext cx="2423160" cy="2752344"/>
+          </a:xfrm>
+          <a:prstGeom prst="roundRect">
+            <a:avLst>
+              <a:gd name="adj" fmla="val 3125"/>
+            </a:avLst>
+          </a:prstGeom>
+          <a:solidFill>
+            <a:srgbClr val="E7F4EE"/>
+          </a:solidFill>
+          <a:ln w="12700">
+            <a:solidFill>
+              <a:srgbClr val="D8DCE4"/>
+            </a:solidFill>
+            <a:prstDash val="solid"/>
+          </a:ln>
+        </p:spPr>
+        <p:txBody>
+          <a:bodyPr/>
+          <a:lstStyle/>
+          <a:p>
+            <a:endParaRPr lang="en-US"/>
+          </a:p>
+        </p:txBody>
+      </p:sp>
+      <p:sp>
+        <p:nvSpPr>
+          <p:cNvPr id="19" name="Shape 17">
+            <a:extLst>
+              <a:ext uri="{C183D7F6-B498-43B3-948B-1728B52AA6E4}">
+                <adec:decorative xmlns:adec="http://schemas.microsoft.com/office/drawing/2017/decorative" val="1"/>
+              </a:ext>
+            </a:extLst>
+          </p:cNvPr>
+          <p:cNvSpPr/>
+          <p:nvPr/>
+        </p:nvSpPr>
+        <p:spPr>
+          <a:xfrm>
+            <a:off x="6556248" y="3630168"/>
+            <a:ext cx="438912" cy="438912"/>
+          </a:xfrm>
+          <a:prstGeom prst="ellipse">
+            <a:avLst/>
+          </a:prstGeom>
+          <a:solidFill>
+            <a:srgbClr val="0B7049"/>
+          </a:solidFill>
+          <a:ln w="12700">
+            <a:solidFill>
+              <a:srgbClr val="0B7049"/>
+            </a:solidFill>
+            <a:prstDash val="solid"/>
+          </a:ln>
+        </p:spPr>
+        <p:txBody>
+          <a:bodyPr/>
+          <a:lstStyle/>
+          <a:p>
+            <a:endParaRPr lang="en-US"/>
+          </a:p>
+        </p:txBody>
+      </p:sp>
+      <p:sp>
+        <p:nvSpPr>
+          <p:cNvPr id="20" name="Text 18"/>
+          <p:cNvSpPr/>
+          <p:nvPr/>
+        </p:nvSpPr>
+        <p:spPr>
+          <a:xfrm>
+            <a:off x="6556248" y="3630168"/>
+            <a:ext cx="438912" cy="438912"/>
+          </a:xfrm>
+          <a:prstGeom prst="rect">
+            <a:avLst/>
+          </a:prstGeom>
+          <a:noFill/>
+          <a:ln/>
+        </p:spPr>
+        <p:txBody>
+          <a:bodyPr wrap="square" lIns="0" tIns="0" rIns="0" bIns="0" rtlCol="0" anchor="ctr">
+            <a:normAutofit/>
+          </a:bodyPr>
+          <a:lstStyle/>
+          <a:p>
+            <a:pPr marL="0" indent="0" algn="ctr">
+              <a:buNone/>
+            </a:pPr>
+            <a:r>
+              <a:rPr lang="en-US" sz="1000" b="1" dirty="0">
+                <a:solidFill>
+                  <a:srgbClr val="FFFFFF"/>
+                </a:solidFill>
+                <a:latin typeface="Aptos" pitchFamily="34" charset="0"/>
+                <a:ea typeface="Aptos" pitchFamily="34" charset="-122"/>
+                <a:cs typeface="Aptos" pitchFamily="34" charset="-120"/>
+              </a:rPr>
+              <a:t>3</a:t>
+            </a:r>
+            <a:endParaRPr lang="en-US" sz="1000" dirty="0"/>
+          </a:p>
+        </p:txBody>
+      </p:sp>
+      <p:sp>
+        <p:nvSpPr>
+          <p:cNvPr id="21" name="Text 19"/>
+          <p:cNvSpPr/>
+          <p:nvPr/>
+        </p:nvSpPr>
+        <p:spPr>
+          <a:xfrm>
+            <a:off x="6574536" y="4251960"/>
+            <a:ext cx="2057400" cy="365760"/>
+          </a:xfrm>
+          <a:prstGeom prst="rect">
+            <a:avLst/>
+          </a:prstGeom>
+          <a:noFill/>
+          <a:ln/>
+        </p:spPr>
+        <p:txBody>
+          <a:bodyPr wrap="square" lIns="0" tIns="0" rIns="0" bIns="0" rtlCol="0" anchor="ctr">
+            <a:normAutofit/>
+          </a:bodyPr>
+          <a:lstStyle/>
+          <a:p>
+            <a:pPr marL="0" indent="0" algn="ctr">
+              <a:buNone/>
+            </a:pPr>
+            <a:r>
+              <a:rPr lang="en-US" sz="1100" b="1" dirty="0">
+                <a:solidFill>
+                  <a:srgbClr val="17254E"/>
+                </a:solidFill>
+                <a:latin typeface="Aptos" pitchFamily="34" charset="0"/>
+                <a:ea typeface="Aptos" pitchFamily="34" charset="-122"/>
+                <a:cs typeface="Aptos" pitchFamily="34" charset="-120"/>
+              </a:rPr>
+              <a:t>+ PROJECT MEMORY</a:t>
+            </a:r>
+            <a:endParaRPr lang="en-US" sz="1100" dirty="0"/>
+          </a:p>
+        </p:txBody>
+      </p:sp>
+      <p:sp>
+        <p:nvSpPr>
+          <p:cNvPr id="22" name="Text 20"/>
+          <p:cNvSpPr/>
+          <p:nvPr/>
+        </p:nvSpPr>
+        <p:spPr>
+          <a:xfrm>
+            <a:off x="6620256" y="4727448"/>
+            <a:ext cx="1965960" cy="896112"/>
+          </a:xfrm>
+          <a:prstGeom prst="rect">
+            <a:avLst/>
+          </a:prstGeom>
+          <a:noFill/>
+          <a:ln/>
+        </p:spPr>
+        <p:txBody>
+          <a:bodyPr wrap="square" lIns="0" tIns="0" rIns="0" bIns="0" rtlCol="0" anchor="t">
+            <a:normAutofit/>
+          </a:bodyPr>
+          <a:lstStyle/>
+          <a:p>
+            <a:pPr marL="0" indent="0" algn="ctr">
+              <a:buNone/>
+            </a:pPr>
+            <a:r>
+              <a:rPr lang="en-US" sz="1100" dirty="0">
+                <a:solidFill>
+                  <a:srgbClr val="202532"/>
+                </a:solidFill>
+                <a:latin typeface="Aptos" pitchFamily="34" charset="0"/>
+                <a:ea typeface="Aptos" pitchFamily="34" charset="-122"/>
+                <a:cs typeface="Aptos" pitchFamily="34" charset="-120"/>
+              </a:rPr>
+              <a:t>Design records, previous prompts, archived iterations, and verified decisions</a:t>
+            </a:r>
+            <a:endParaRPr lang="en-US" sz="1100" dirty="0"/>
+          </a:p>
+        </p:txBody>
+      </p:sp>
+      <p:sp>
+        <p:nvSpPr>
+          <p:cNvPr id="23" name="Shape 21">
+            <a:extLst>
+              <a:ext uri="{C183D7F6-B498-43B3-948B-1728B52AA6E4}">
+                <adec:decorative xmlns:adec="http://schemas.microsoft.com/office/drawing/2017/decorative" val="1"/>
+              </a:ext>
+            </a:extLst>
+          </p:cNvPr>
+          <p:cNvSpPr/>
+          <p:nvPr/>
+        </p:nvSpPr>
+        <p:spPr>
+          <a:xfrm>
+            <a:off x="9153144" y="2752344"/>
+            <a:ext cx="2423160" cy="3465576"/>
+          </a:xfrm>
+          <a:prstGeom prst="roundRect">
+            <a:avLst>
+              <a:gd name="adj" fmla="val 3019"/>
+            </a:avLst>
+          </a:prstGeom>
+          <a:solidFill>
+            <a:srgbClr val="DDE7F6"/>
+          </a:solidFill>
+          <a:ln w="12700">
+            <a:solidFill>
+              <a:srgbClr val="D8DCE4"/>
+            </a:solidFill>
+            <a:prstDash val="solid"/>
+          </a:ln>
+        </p:spPr>
+        <p:txBody>
+          <a:bodyPr/>
+          <a:lstStyle/>
+          <a:p>
+            <a:endParaRPr lang="en-US"/>
+          </a:p>
+        </p:txBody>
+      </p:sp>
+      <p:sp>
+        <p:nvSpPr>
+          <p:cNvPr id="24" name="Shape 22">
+            <a:extLst>
+              <a:ext uri="{C183D7F6-B498-43B3-948B-1728B52AA6E4}">
+                <adec:decorative xmlns:adec="http://schemas.microsoft.com/office/drawing/2017/decorative" val="1"/>
+              </a:ext>
+            </a:extLst>
+          </p:cNvPr>
+          <p:cNvSpPr/>
+          <p:nvPr/>
+        </p:nvSpPr>
+        <p:spPr>
+          <a:xfrm>
+            <a:off x="9317736" y="2916936"/>
+            <a:ext cx="438912" cy="438912"/>
+          </a:xfrm>
+          <a:prstGeom prst="ellipse">
+            <a:avLst/>
+          </a:prstGeom>
+          <a:solidFill>
+            <a:srgbClr val="40547F"/>
+          </a:solidFill>
+          <a:ln w="12700">
+            <a:solidFill>
+              <a:srgbClr val="40547F"/>
+            </a:solidFill>
+            <a:prstDash val="solid"/>
+          </a:ln>
+        </p:spPr>
+        <p:txBody>
+          <a:bodyPr/>
+          <a:lstStyle/>
+          <a:p>
+            <a:endParaRPr lang="en-US"/>
+          </a:p>
+        </p:txBody>
+      </p:sp>
+      <p:sp>
+        <p:nvSpPr>
+          <p:cNvPr id="25" name="Text 23"/>
+          <p:cNvSpPr/>
+          <p:nvPr/>
+        </p:nvSpPr>
+        <p:spPr>
+          <a:xfrm>
+            <a:off x="9317736" y="2916936"/>
+            <a:ext cx="438912" cy="438912"/>
+          </a:xfrm>
+          <a:prstGeom prst="rect">
+            <a:avLst/>
+          </a:prstGeom>
+          <a:noFill/>
+          <a:ln/>
+        </p:spPr>
+        <p:txBody>
+          <a:bodyPr wrap="square" lIns="0" tIns="0" rIns="0" bIns="0" rtlCol="0" anchor="ctr">
+            <a:normAutofit/>
+          </a:bodyPr>
+          <a:lstStyle/>
+          <a:p>
+            <a:pPr marL="0" indent="0" algn="ctr">
+              <a:buNone/>
+            </a:pPr>
+            <a:r>
+              <a:rPr lang="en-US" sz="1000" b="1" dirty="0">
+                <a:solidFill>
+                  <a:srgbClr val="FFFFFF"/>
+                </a:solidFill>
+                <a:latin typeface="Aptos" pitchFamily="34" charset="0"/>
+                <a:ea typeface="Aptos" pitchFamily="34" charset="-122"/>
+                <a:cs typeface="Aptos" pitchFamily="34" charset="-120"/>
+              </a:rPr>
+              <a:t>4</a:t>
+            </a:r>
+            <a:endParaRPr lang="en-US" sz="1000" dirty="0"/>
+          </a:p>
+        </p:txBody>
+      </p:sp>
+      <p:sp>
+        <p:nvSpPr>
+          <p:cNvPr id="26" name="Text 24"/>
+          <p:cNvSpPr/>
+          <p:nvPr/>
+        </p:nvSpPr>
+        <p:spPr>
+          <a:xfrm>
+            <a:off x="9336024" y="3538728"/>
+            <a:ext cx="2057400" cy="365760"/>
+          </a:xfrm>
+          <a:prstGeom prst="rect">
+            <a:avLst/>
+          </a:prstGeom>
+          <a:noFill/>
+          <a:ln/>
+        </p:spPr>
+        <p:txBody>
+          <a:bodyPr wrap="square" lIns="0" tIns="0" rIns="0" bIns="0" rtlCol="0" anchor="ctr">
+            <a:normAutofit/>
+          </a:bodyPr>
+          <a:lstStyle/>
+          <a:p>
+            <a:pPr marL="0" indent="0" algn="ctr">
+              <a:buNone/>
+            </a:pPr>
+            <a:r>
+              <a:rPr lang="en-US" sz="1100" b="1" dirty="0">
+                <a:solidFill>
+                  <a:srgbClr val="17254E"/>
+                </a:solidFill>
+                <a:latin typeface="Aptos" pitchFamily="34" charset="0"/>
+                <a:ea typeface="Aptos" pitchFamily="34" charset="-122"/>
+                <a:cs typeface="Aptos" pitchFamily="34" charset="-120"/>
+              </a:rPr>
+              <a:t>+ CONNECTED SOURCES</a:t>
+            </a:r>
+            <a:endParaRPr lang="en-US" sz="1100" dirty="0"/>
+          </a:p>
+        </p:txBody>
+      </p:sp>
+      <p:sp>
+        <p:nvSpPr>
+          <p:cNvPr id="27" name="Text 25"/>
+          <p:cNvSpPr/>
+          <p:nvPr/>
+        </p:nvSpPr>
+        <p:spPr>
+          <a:xfrm>
+            <a:off x="9381744" y="4014216"/>
+            <a:ext cx="1965960" cy="1609344"/>
+          </a:xfrm>
+          <a:prstGeom prst="rect">
+            <a:avLst/>
+          </a:prstGeom>
+          <a:noFill/>
+          <a:ln/>
+        </p:spPr>
+        <p:txBody>
+          <a:bodyPr wrap="square" lIns="0" tIns="0" rIns="0" bIns="0" rtlCol="0" anchor="t">
+            <a:normAutofit/>
+          </a:bodyPr>
+          <a:lstStyle/>
+          <a:p>
+            <a:pPr marL="0" indent="0" algn="ctr">
+              <a:buNone/>
+            </a:pPr>
+            <a:r>
+              <a:rPr lang="en-US" sz="1100" dirty="0">
+                <a:solidFill>
+                  <a:srgbClr val="202532"/>
+                </a:solidFill>
+                <a:latin typeface="Aptos" pitchFamily="34" charset="0"/>
+                <a:ea typeface="Aptos" pitchFamily="34" charset="-122"/>
+                <a:cs typeface="Aptos" pitchFamily="34" charset="-120"/>
+              </a:rPr>
+              <a:t>Institutional resources, current sources, APIs, and search—when appropriate</a:t>
+            </a:r>
+            <a:endParaRPr lang="en-US" sz="1100" dirty="0"/>
+          </a:p>
+        </p:txBody>
+      </p:sp>
+      <p:sp>
+        <p:nvSpPr>
+          <p:cNvPr id="7" name="Text 5"/>
+          <p:cNvSpPr/>
+          <p:nvPr/>
+        </p:nvSpPr>
+        <p:spPr>
+          <a:xfrm>
+            <a:off x="594360" y="6510528"/>
+            <a:ext cx="5943600" cy="164592"/>
+          </a:xfrm>
+          <a:prstGeom prst="rect">
+            <a:avLst/>
+          </a:prstGeom>
+          <a:noFill/>
+          <a:ln/>
+        </p:spPr>
+        <p:txBody>
+          <a:bodyPr wrap="square" lIns="0" tIns="0" rIns="0" bIns="0" rtlCol="0" anchor="ctr">
+            <a:normAutofit/>
+          </a:bodyPr>
+          <a:lstStyle/>
+          <a:p>
+            <a:pPr marL="0" indent="0">
+              <a:buNone/>
+            </a:pPr>
+            <a:r>
+              <a:rPr lang="en-US" sz="800" dirty="0">
+                <a:solidFill>
+                  <a:srgbClr val="576173"/>
+                </a:solidFill>
+                <a:latin typeface="Aptos" pitchFamily="34" charset="0"/>
+                <a:ea typeface="Aptos" pitchFamily="34" charset="-122"/>
+                <a:cs typeface="Aptos" pitchFamily="34" charset="-120"/>
+              </a:rPr>
+              <a:t>Hillsborough College  |  Summer Institute 2026</a:t>
+            </a:r>
+            <a:endParaRPr lang="en-US" sz="800" dirty="0"/>
           </a:p>
         </p:txBody>
       </p:sp>

</xml_diff>